<commit_message>
Update internship results presentation
</commit_message>
<xml_diff>
--- a/インターン成果報告.pptx
+++ b/インターン成果報告.pptx
@@ -4,9 +4,6 @@
   <p:sldMasterIdLst>
     <p:sldMasterId id="2147483648" r:id="rId1"/>
   </p:sldMasterIdLst>
-  <p:notesMasterIdLst>
-    <p:notesMasterId r:id="rId18"/>
-  </p:notesMasterIdLst>
   <p:sldIdLst>
     <p:sldId id="256" r:id="rId2"/>
     <p:sldId id="257" r:id="rId3"/>
@@ -25,6 +22,9 @@
     <p:sldId id="270" r:id="rId16"/>
     <p:sldId id="271" r:id="rId17"/>
   </p:sldIdLst>
+  <p:notesMasterIdLst>
+    <p:notesMasterId r:id="rId18"/>
+  </p:notesMasterIdLst>
   <p:sldSz cx="12192000" cy="6858000"/>
   <p:notesSz cx="6858000" cy="12192000"/>
   <p:defaultTextStyle>
@@ -119,11 +119,6 @@
       </a:defRPr>
     </a:lvl9pPr>
   </p:defaultTextStyle>
-  <p:extLst>
-    <p:ext uri="{EFAFB233-063F-42B5-8137-9DF3F51BA10A}">
-      <p15:sldGuideLst xmlns:p15="http://schemas.microsoft.com/office/powerpoint/2012/main"/>
-    </p:ext>
-  </p:extLst>
 </p:presentation>
 </file>
 
@@ -149,17 +144,241 @@
           <a:chExt cx="0" cy="0"/>
         </a:xfrm>
       </p:grpSpPr>
+      <p:sp>
+        <p:nvSpPr>
+          <p:cNvPr id="2" name="Header Placeholder 1"/>
+          <p:cNvSpPr>
+            <a:spLocks noGrp="1"/>
+          </p:cNvSpPr>
+          <p:nvPr>
+            <p:ph type="hdr" sz="quarter"/>
+          </p:nvPr>
+        </p:nvSpPr>
+        <p:spPr>
+          <a:xfrm>
+            <a:off x="0" y="0"/>
+            <a:ext cx="2971800" cy="458788"/>
+          </a:xfrm>
+          <a:prstGeom prst="rect">
+            <a:avLst/>
+          </a:prstGeom>
+        </p:spPr>
+        <p:txBody>
+          <a:bodyPr vert="horz" lIns="91440" tIns="45720" rIns="91440" bIns="45720" rtlCol="0"/>
+          <a:lstStyle>
+            <a:lvl1pPr algn="l">
+              <a:defRPr sz="1200"/>
+            </a:lvl1pPr>
+          </a:lstStyle>
+          <a:p>
+            <a:endParaRPr lang="en-US"/>
+          </a:p>
+        </p:txBody>
+      </p:sp>
+      <p:sp>
+        <p:nvSpPr>
+          <p:cNvPr id="3" name="Date Placeholder 2"/>
+          <p:cNvSpPr>
+            <a:spLocks noGrp="1"/>
+          </p:cNvSpPr>
+          <p:nvPr>
+            <p:ph type="dt" idx="1"/>
+          </p:nvPr>
+        </p:nvSpPr>
+        <p:spPr>
+          <a:xfrm>
+            <a:off x="3884613" y="0"/>
+            <a:ext cx="2971800" cy="458788"/>
+          </a:xfrm>
+          <a:prstGeom prst="rect">
+            <a:avLst/>
+          </a:prstGeom>
+        </p:spPr>
+        <p:txBody>
+          <a:bodyPr vert="horz" lIns="91440" tIns="45720" rIns="91440" bIns="45720" rtlCol="0"/>
+          <a:lstStyle>
+            <a:lvl1pPr algn="r">
+              <a:defRPr sz="1200"/>
+            </a:lvl1pPr>
+          </a:lstStyle>
+          <a:p>
+            <a:fld id="{5282F153-3F37-0F45-9E97-73ACFA13230C}" type="datetimeFigureOut">
+              <a:rPr lang="en-US"/>
+              <a:t>7/23/19</a:t>
+            </a:fld>
+            <a:endParaRPr lang="en-US"/>
+          </a:p>
+        </p:txBody>
+      </p:sp>
+      <p:sp>
+        <p:nvSpPr>
+          <p:cNvPr id="4" name="Slide Image Placeholder 3"/>
+          <p:cNvSpPr>
+            <a:spLocks noGrp="1" noRot="1" noChangeAspect="1"/>
+          </p:cNvSpPr>
+          <p:nvPr>
+            <p:ph type="sldImg" idx="2"/>
+          </p:nvPr>
+        </p:nvSpPr>
+        <p:spPr>
+          <a:xfrm>
+            <a:off x="685800" y="1143000"/>
+            <a:ext cx="5486400" cy="3086100"/>
+          </a:xfrm>
+          <a:prstGeom prst="rect">
+            <a:avLst/>
+          </a:prstGeom>
+          <a:noFill/>
+          <a:ln w="12700">
+            <a:solidFill>
+              <a:prstClr val="black"/>
+            </a:solidFill>
+          </a:ln>
+        </p:spPr>
+        <p:txBody>
+          <a:bodyPr vert="horz" lIns="91440" tIns="45720" rIns="91440" bIns="45720" rtlCol="0" anchor="ctr"/>
+          <a:lstStyle/>
+          <a:p>
+            <a:endParaRPr lang="en-US"/>
+          </a:p>
+        </p:txBody>
+      </p:sp>
+      <p:sp>
+        <p:nvSpPr>
+          <p:cNvPr id="5" name="Notes Placeholder 4"/>
+          <p:cNvSpPr>
+            <a:spLocks noGrp="1"/>
+          </p:cNvSpPr>
+          <p:nvPr>
+            <p:ph type="body" sz="quarter" idx="3"/>
+          </p:nvPr>
+        </p:nvSpPr>
+        <p:spPr>
+          <a:xfrm>
+            <a:off x="685800" y="4400550"/>
+            <a:ext cx="5486400" cy="3600450"/>
+          </a:xfrm>
+          <a:prstGeom prst="rect">
+            <a:avLst/>
+          </a:prstGeom>
+        </p:spPr>
+        <p:txBody>
+          <a:bodyPr vert="horz" lIns="91440" tIns="45720" rIns="91440" bIns="45720" rtlCol="0"/>
+          <a:lstStyle/>
+          <a:p>
+            <a:pPr lvl="0"/>
+            <a:r>
+              <a:rPr lang="en-US"/>
+              <a:t>Click to edit Master text styles</a:t>
+            </a:r>
+          </a:p>
+          <a:p>
+            <a:pPr lvl="1"/>
+            <a:r>
+              <a:rPr lang="en-US"/>
+              <a:t>Second level</a:t>
+            </a:r>
+          </a:p>
+          <a:p>
+            <a:pPr lvl="2"/>
+            <a:r>
+              <a:rPr lang="en-US"/>
+              <a:t>Third level</a:t>
+            </a:r>
+          </a:p>
+          <a:p>
+            <a:pPr lvl="3"/>
+            <a:r>
+              <a:rPr lang="en-US"/>
+              <a:t>Fourth level</a:t>
+            </a:r>
+          </a:p>
+          <a:p>
+            <a:pPr lvl="4"/>
+            <a:r>
+              <a:rPr lang="en-US"/>
+              <a:t>Fifth level</a:t>
+            </a:r>
+          </a:p>
+        </p:txBody>
+      </p:sp>
+      <p:sp>
+        <p:nvSpPr>
+          <p:cNvPr id="6" name="Footer Placeholder 5"/>
+          <p:cNvSpPr>
+            <a:spLocks noGrp="1"/>
+          </p:cNvSpPr>
+          <p:nvPr>
+            <p:ph type="ftr" sz="quarter" idx="4"/>
+          </p:nvPr>
+        </p:nvSpPr>
+        <p:spPr>
+          <a:xfrm>
+            <a:off x="0" y="8685213"/>
+            <a:ext cx="2971800" cy="458787"/>
+          </a:xfrm>
+          <a:prstGeom prst="rect">
+            <a:avLst/>
+          </a:prstGeom>
+        </p:spPr>
+        <p:txBody>
+          <a:bodyPr vert="horz" lIns="91440" tIns="45720" rIns="91440" bIns="45720" rtlCol="0" anchor="b"/>
+          <a:lstStyle>
+            <a:lvl1pPr algn="l">
+              <a:defRPr sz="1200"/>
+            </a:lvl1pPr>
+          </a:lstStyle>
+          <a:p>
+            <a:endParaRPr lang="en-US"/>
+          </a:p>
+        </p:txBody>
+      </p:sp>
+      <p:sp>
+        <p:nvSpPr>
+          <p:cNvPr id="7" name="Slide Number Placeholder 6"/>
+          <p:cNvSpPr>
+            <a:spLocks noGrp="1"/>
+          </p:cNvSpPr>
+          <p:nvPr>
+            <p:ph type="sldNum" sz="quarter" idx="5"/>
+          </p:nvPr>
+        </p:nvSpPr>
+        <p:spPr>
+          <a:xfrm>
+            <a:off x="3884613" y="8685213"/>
+            <a:ext cx="2971800" cy="458787"/>
+          </a:xfrm>
+          <a:prstGeom prst="rect">
+            <a:avLst/>
+          </a:prstGeom>
+        </p:spPr>
+        <p:txBody>
+          <a:bodyPr vert="horz" lIns="91440" tIns="45720" rIns="91440" bIns="45720" rtlCol="0" anchor="b"/>
+          <a:lstStyle>
+            <a:lvl1pPr algn="r">
+              <a:defRPr sz="1200"/>
+            </a:lvl1pPr>
+          </a:lstStyle>
+          <a:p>
+            <a:fld id="{CE5E9CC1-C706-0F49-92D6-E571CC5EEA8F}" type="slidenum">
+              <a:rPr lang="en-US"/>
+              <a:t>‹#›</a:t>
+            </a:fld>
+            <a:endParaRPr lang="en-US"/>
+          </a:p>
+        </p:txBody>
+      </p:sp>
     </p:spTree>
     <p:extLst>
       <p:ext uri="{BB962C8B-B14F-4D97-AF65-F5344CB8AC3E}">
-        <p14:creationId xmlns:p14="http://schemas.microsoft.com/office/powerpoint/2010/main" val="2684288069"/>
+        <p14:creationId xmlns:p14="http://schemas.microsoft.com/office/powerpoint/2010/main" val="1024086991"/>
       </p:ext>
     </p:extLst>
   </p:cSld>
   <p:clrMap bg1="lt1" tx1="dk1" bg2="lt2" tx2="dk2" accent1="accent1" accent2="accent2" accent3="accent3" accent4="accent4" accent5="accent5" accent6="accent6" hlink="hlink" folHlink="folHlink"/>
   <p:notesStyle>
     <a:lvl1pPr marL="0" algn="l" defTabSz="914400" rtl="0" eaLnBrk="1" latinLnBrk="0" hangingPunct="1">
-      <a:defRPr kumimoji="1" sz="1200" kern="1200">
+      <a:defRPr sz="1200" kern="1200">
         <a:solidFill>
           <a:schemeClr val="tx1"/>
         </a:solidFill>
@@ -169,7 +388,7 @@
       </a:defRPr>
     </a:lvl1pPr>
     <a:lvl2pPr marL="457200" algn="l" defTabSz="914400" rtl="0" eaLnBrk="1" latinLnBrk="0" hangingPunct="1">
-      <a:defRPr kumimoji="1" sz="1200" kern="1200">
+      <a:defRPr sz="1200" kern="1200">
         <a:solidFill>
           <a:schemeClr val="tx1"/>
         </a:solidFill>
@@ -179,7 +398,7 @@
       </a:defRPr>
     </a:lvl2pPr>
     <a:lvl3pPr marL="914400" algn="l" defTabSz="914400" rtl="0" eaLnBrk="1" latinLnBrk="0" hangingPunct="1">
-      <a:defRPr kumimoji="1" sz="1200" kern="1200">
+      <a:defRPr sz="1200" kern="1200">
         <a:solidFill>
           <a:schemeClr val="tx1"/>
         </a:solidFill>
@@ -189,7 +408,7 @@
       </a:defRPr>
     </a:lvl3pPr>
     <a:lvl4pPr marL="1371600" algn="l" defTabSz="914400" rtl="0" eaLnBrk="1" latinLnBrk="0" hangingPunct="1">
-      <a:defRPr kumimoji="1" sz="1200" kern="1200">
+      <a:defRPr sz="1200" kern="1200">
         <a:solidFill>
           <a:schemeClr val="tx1"/>
         </a:solidFill>
@@ -199,7 +418,7 @@
       </a:defRPr>
     </a:lvl4pPr>
     <a:lvl5pPr marL="1828800" algn="l" defTabSz="914400" rtl="0" eaLnBrk="1" latinLnBrk="0" hangingPunct="1">
-      <a:defRPr kumimoji="1" sz="1200" kern="1200">
+      <a:defRPr sz="1200" kern="1200">
         <a:solidFill>
           <a:schemeClr val="tx1"/>
         </a:solidFill>
@@ -209,7 +428,7 @@
       </a:defRPr>
     </a:lvl5pPr>
     <a:lvl6pPr marL="2286000" algn="l" defTabSz="914400" rtl="0" eaLnBrk="1" latinLnBrk="0" hangingPunct="1">
-      <a:defRPr kumimoji="1" sz="1200" kern="1200">
+      <a:defRPr sz="1200" kern="1200">
         <a:solidFill>
           <a:schemeClr val="tx1"/>
         </a:solidFill>
@@ -219,7 +438,7 @@
       </a:defRPr>
     </a:lvl6pPr>
     <a:lvl7pPr marL="2743200" algn="l" defTabSz="914400" rtl="0" eaLnBrk="1" latinLnBrk="0" hangingPunct="1">
-      <a:defRPr kumimoji="1" sz="1200" kern="1200">
+      <a:defRPr sz="1200" kern="1200">
         <a:solidFill>
           <a:schemeClr val="tx1"/>
         </a:solidFill>
@@ -229,7 +448,7 @@
       </a:defRPr>
     </a:lvl7pPr>
     <a:lvl8pPr marL="3200400" algn="l" defTabSz="914400" rtl="0" eaLnBrk="1" latinLnBrk="0" hangingPunct="1">
-      <a:defRPr kumimoji="1" sz="1200" kern="1200">
+      <a:defRPr sz="1200" kern="1200">
         <a:solidFill>
           <a:schemeClr val="tx1"/>
         </a:solidFill>
@@ -239,7 +458,7 @@
       </a:defRPr>
     </a:lvl8pPr>
     <a:lvl9pPr marL="3657600" algn="l" defTabSz="914400" rtl="0" eaLnBrk="1" latinLnBrk="0" hangingPunct="1">
-      <a:defRPr kumimoji="1" sz="1200" kern="1200">
+      <a:defRPr sz="1200" kern="1200">
         <a:solidFill>
           <a:schemeClr val="tx1"/>
         </a:solidFill>
@@ -300,6 +519,7 @@
               <a:rPr lang="en-US" dirty="0"/>
               <a:t>自己紹介。インターンで取り組んだテーマの位置づけを一言で述べる。</a:t>
             </a:r>
+            <a:endParaRPr lang="en-US" dirty="0"/>
           </a:p>
         </p:txBody>
       </p:sp>
@@ -387,6 +607,7 @@
               <a:rPr lang="en-US" dirty="0"/>
               <a:t>ここから先は質疑用の付録。時間があれば構造化（A-1〜A-3）と構造比較（A-4〜A-6）を説明する。</a:t>
             </a:r>
+            <a:endParaRPr lang="en-US" dirty="0"/>
           </a:p>
         </p:txBody>
       </p:sp>
@@ -474,6 +695,7 @@
               <a:rPr lang="en-US" dirty="0"/>
               <a:t>左：原文を7種類の点に分解する。右：因果などの関係を辺ではなく点として置くことで、条件や確からしさをその関係に付けられる。</a:t>
             </a:r>
+            <a:endParaRPr lang="en-US" dirty="0"/>
           </a:p>
         </p:txBody>
       </p:sp>
@@ -561,6 +783,7 @@
               <a:rPr lang="en-US" dirty="0"/>
               <a:t>上段：原文の意味を決める3つの情報。これを残すかどうかで、後の比較の精度が変わる。下段：分野をまたぐために言葉づかいをそろえるが、違う意味まで統合しない。</a:t>
             </a:r>
+            <a:endParaRPr lang="en-US" dirty="0"/>
           </a:p>
         </p:txBody>
       </p:sp>
@@ -648,6 +871,7 @@
               <a:rPr lang="en-US" dirty="0"/>
               <a:t>抽出でいちばん怖いのは、もっともらしい因果を足してしまうこと。足さないための規則と、表せない部分の置き場をセットで決めている。</a:t>
             </a:r>
+            <a:endParaRPr lang="en-US" dirty="0"/>
           </a:p>
         </p:txBody>
       </p:sp>
@@ -735,6 +959,7 @@
               <a:rPr lang="en-US" dirty="0"/>
               <a:t>比較の単位をどう切り出すか。意味を決める引数を落とすと、形だけ似た別物が一致してしまうため、閉じた範囲で切り出す。</a:t>
             </a:r>
+            <a:endParaRPr lang="en-US" dirty="0"/>
           </a:p>
         </p:txBody>
       </p:sp>
@@ -822,6 +1047,7 @@
               <a:rPr lang="en-US" dirty="0"/>
               <a:t>比較の設計で最も効くところ。使う情報を増やすと誤った一致は減るが、厳しくしすぎると分野をまたいだ一致が消える。そのバランスを実験で確かめている。</a:t>
             </a:r>
+            <a:endParaRPr lang="en-US" dirty="0"/>
           </a:p>
         </p:txBody>
       </p:sp>
@@ -909,6 +1135,7 @@
               <a:rPr lang="en-US" dirty="0"/>
               <a:t>照合は2段階。粗い条件はあくまで絞り込みで、一致の証明にはしない。保留した断片は辞書を直してから再探索する。最後の枠は、比較方式を差し替えて効果を測れるようにしてあるという話。</a:t>
             </a:r>
+            <a:endParaRPr lang="en-US" dirty="0"/>
           </a:p>
         </p:txBody>
       </p:sp>
@@ -996,6 +1223,7 @@
               <a:rPr lang="en-US" dirty="0"/>
               <a:t>全体の流れ。手法は概要と詳細の2枚、結果と考察はまとめて3章、最後に振り返り。付録は質疑用。</a:t>
             </a:r>
+            <a:endParaRPr lang="en-US" dirty="0"/>
           </a:p>
         </p:txBody>
       </p:sp>
@@ -1083,6 +1311,7 @@
               <a:rPr lang="en-US" dirty="0"/>
               <a:t>左：いま困っていること。右：それに対してやりたいこと。下段：そのために今取り組んでいる範囲（実験は進行中で、結果はこの後のスライドで触れる）。</a:t>
             </a:r>
+            <a:endParaRPr lang="en-US" dirty="0"/>
           </a:p>
         </p:txBody>
       </p:sp>
@@ -1168,8 +1397,9 @@
           <a:p>
             <a:r>
               <a:rPr lang="en-US" dirty="0"/>
-              <a:t>4段階の流れ。1〜2がLLM、3がプログラム、4が質問応答。下段は「なぜこの分け方にするか」。手法はまだ検討中である点を口頭でも触れる。</a:t>
-            </a:r>
+              <a:t>上段は4段階の流れ。1〜2がLLM、3がプログラム、4が質問応答。下段は理由を①→②→③でつなぐ：①分野が違っても関係は残る、②その関係のまとまりこそが考え方、③だから繰り返す構造は考え方の候補になる。②の根拠としてStructure-Mapping（類推では対象の属性より関係の対応づけが中核）を挙げる。最後に速度の利点を補足。手法はまだ検討中である点も触れる。</a:t>
+            </a:r>
+            <a:endParaRPr lang="en-US" dirty="0"/>
           </a:p>
         </p:txBody>
       </p:sp>
@@ -1257,6 +1487,7 @@
               <a:rPr lang="en-US" dirty="0"/>
               <a:t>左→中→右の順に話す。中央のCLAIMが要：因果・兆候・必要・順序を混ぜず、条件や「〜のことがある」を関係そのものに結びつけられる。比較もこのCLAIMを起点に切り出すので、意味の欠けた断片どうしは一致しない。</a:t>
             </a:r>
+            <a:endParaRPr lang="en-US" dirty="0"/>
           </a:p>
         </p:txBody>
       </p:sp>
@@ -1340,6 +1571,10 @@
           <a:bodyPr/>
           <a:lstStyle/>
           <a:p>
+            <a:r>
+              <a:rPr lang="en-US" dirty="0"/>
+              <a:t/>
+            </a:r>
             <a:endParaRPr lang="en-US" dirty="0"/>
           </a:p>
         </p:txBody>
@@ -1424,6 +1659,10 @@
           <a:bodyPr/>
           <a:lstStyle/>
           <a:p>
+            <a:r>
+              <a:rPr lang="en-US" dirty="0"/>
+              <a:t/>
+            </a:r>
             <a:endParaRPr lang="en-US" dirty="0"/>
           </a:p>
         </p:txBody>
@@ -1512,6 +1751,7 @@
               <a:rPr lang="en-US" dirty="0"/>
               <a:t>①AI活用の推進状況と、定例での事例共有から感じた技術への感度の高さ。②いつでも議論できる環境。メンターの方の説明と、まわりの人が自然に議論へ加わってくる雰囲気。③熟練者の方とAIの対話の会に参加して感じた、知識の深さと仕事への誇り。ここでノウハウを残すことの意義を再認識した、という流れで下段へ。</a:t>
             </a:r>
+            <a:endParaRPr lang="en-US" dirty="0"/>
           </a:p>
         </p:txBody>
       </p:sp>
@@ -1595,6 +1835,10 @@
           <a:bodyPr/>
           <a:lstStyle/>
           <a:p>
+            <a:r>
+              <a:rPr lang="en-US" dirty="0"/>
+              <a:t/>
+            </a:r>
             <a:endParaRPr lang="en-US" dirty="0"/>
           </a:p>
         </p:txBody>
@@ -1668,11 +1912,6 @@
 <file path=ppt/slideMasters/slideMaster1.xml><?xml version="1.0" encoding="utf-8"?>
 <p:sldMaster xmlns:a="http://schemas.openxmlformats.org/drawingml/2006/main" xmlns:r="http://schemas.openxmlformats.org/officeDocument/2006/relationships" xmlns:p="http://schemas.openxmlformats.org/presentationml/2006/main">
   <p:cSld>
-    <p:bg>
-      <p:bgRef idx="1001">
-        <a:schemeClr val="bg1"/>
-      </p:bgRef>
-    </p:bg>
     <p:spTree>
       <p:nvGrpSpPr>
         <p:cNvPr id="1" name=""/>
@@ -1955,7 +2194,6 @@
         <a:solidFill>
           <a:srgbClr val="0E2841"/>
         </a:solidFill>
-        <a:effectLst/>
       </p:bgPr>
     </p:bg>
     <p:spTree>
@@ -1996,13 +2234,6 @@
             <a:prstDash val="solid"/>
           </a:ln>
         </p:spPr>
-        <p:txBody>
-          <a:bodyPr/>
-          <a:lstStyle/>
-          <a:p>
-            <a:endParaRPr lang="ja-JP" altLang="en-US"/>
-          </a:p>
-        </p:txBody>
       </p:sp>
       <p:sp>
         <p:nvSpPr>
@@ -2030,13 +2261,6 @@
             <a:prstDash val="solid"/>
           </a:ln>
         </p:spPr>
-        <p:txBody>
-          <a:bodyPr/>
-          <a:lstStyle/>
-          <a:p>
-            <a:endParaRPr lang="ja-JP" altLang="en-US"/>
-          </a:p>
-        </p:txBody>
       </p:sp>
       <p:sp>
         <p:nvSpPr>
@@ -2059,7 +2283,7 @@
           <a:bodyPr wrap="square" lIns="0" tIns="0" rIns="0" bIns="0" rtlCol="0" anchor="ctr"/>
           <a:lstStyle/>
           <a:p>
-            <a:pPr marL="0" indent="0">
+            <a:pPr indent="0" marL="0">
               <a:buNone/>
             </a:pPr>
             <a:r>
@@ -2098,7 +2322,7 @@
           <a:bodyPr wrap="square" lIns="0" tIns="0" rIns="0" bIns="0" rtlCol="0" anchor="ctr"/>
           <a:lstStyle/>
           <a:p>
-            <a:pPr marL="0" indent="0">
+            <a:pPr indent="0" marL="0">
               <a:buNone/>
             </a:pPr>
             <a:r>
@@ -2140,13 +2364,6 @@
             <a:prstDash val="solid"/>
           </a:ln>
         </p:spPr>
-        <p:txBody>
-          <a:bodyPr/>
-          <a:lstStyle/>
-          <a:p>
-            <a:endParaRPr lang="ja-JP" altLang="en-US"/>
-          </a:p>
-        </p:txBody>
       </p:sp>
       <p:sp>
         <p:nvSpPr>
@@ -2169,7 +2386,7 @@
           <a:bodyPr wrap="square" lIns="0" tIns="0" rIns="0" bIns="0" rtlCol="0" anchor="ctr"/>
           <a:lstStyle/>
           <a:p>
-            <a:pPr marL="0" indent="0">
+            <a:pPr indent="0" marL="0">
               <a:buNone/>
             </a:pPr>
             <a:r>
@@ -2203,7 +2420,6 @@
         <a:solidFill>
           <a:srgbClr val="0E2841"/>
         </a:solidFill>
-        <a:effectLst/>
       </p:bgPr>
     </p:bg>
     <p:spTree>
@@ -2244,13 +2460,6 @@
             <a:prstDash val="solid"/>
           </a:ln>
         </p:spPr>
-        <p:txBody>
-          <a:bodyPr/>
-          <a:lstStyle/>
-          <a:p>
-            <a:endParaRPr lang="ja-JP" altLang="en-US"/>
-          </a:p>
-        </p:txBody>
       </p:sp>
       <p:sp>
         <p:nvSpPr>
@@ -2273,11 +2482,11 @@
           <a:bodyPr wrap="square" lIns="0" tIns="0" rIns="0" bIns="0" rtlCol="0" anchor="ctr"/>
           <a:lstStyle/>
           <a:p>
-            <a:pPr marL="0" indent="0">
-              <a:buNone/>
-            </a:pPr>
-            <a:r>
-              <a:rPr lang="en-US" sz="1300" b="1" kern="0" spc="300" dirty="0">
+            <a:pPr indent="0" marL="0">
+              <a:buNone/>
+            </a:pPr>
+            <a:r>
+              <a:rPr lang="en-US" sz="1300" b="1" spc="300" kern="0" dirty="0">
                 <a:solidFill>
                   <a:srgbClr val="CADCFC"/>
                 </a:solidFill>
@@ -2312,7 +2521,7 @@
           <a:bodyPr wrap="square" lIns="0" tIns="0" rIns="0" bIns="0" rtlCol="0" anchor="ctr"/>
           <a:lstStyle/>
           <a:p>
-            <a:pPr marL="0" indent="0">
+            <a:pPr indent="0" marL="0">
               <a:buNone/>
             </a:pPr>
             <a:r>
@@ -2351,7 +2560,7 @@
           <a:bodyPr wrap="square" lIns="0" tIns="0" rIns="0" bIns="0" rtlCol="0" anchor="ctr"/>
           <a:lstStyle/>
           <a:p>
-            <a:pPr marL="0" indent="0">
+            <a:pPr indent="0" marL="0">
               <a:lnSpc>
                 <a:spcPct val="140000"/>
               </a:lnSpc>
@@ -2371,7 +2580,7 @@
             <a:endParaRPr lang="en-US" sz="1700" dirty="0"/>
           </a:p>
           <a:p>
-            <a:pPr marL="0" indent="0">
+            <a:pPr indent="0" marL="0">
               <a:lnSpc>
                 <a:spcPct val="140000"/>
               </a:lnSpc>
@@ -2413,7 +2622,7 @@
           <a:bodyPr wrap="square" lIns="0" tIns="0" rIns="0" bIns="0" rtlCol="0" anchor="ctr"/>
           <a:lstStyle/>
           <a:p>
-            <a:pPr marL="0" indent="0" algn="r">
+            <a:pPr algn="r" indent="0" marL="0">
               <a:buNone/>
             </a:pPr>
             <a:r>
@@ -2447,7 +2656,6 @@
         <a:solidFill>
           <a:srgbClr val="FFFFFF"/>
         </a:solidFill>
-        <a:effectLst/>
       </p:bgPr>
     </p:bg>
     <p:spTree>
@@ -2485,11 +2693,11 @@
           <a:bodyPr wrap="square" lIns="0" tIns="0" rIns="0" bIns="0" rtlCol="0" anchor="ctr"/>
           <a:lstStyle/>
           <a:p>
-            <a:pPr marL="0" indent="0">
-              <a:buNone/>
-            </a:pPr>
-            <a:r>
-              <a:rPr lang="en-US" sz="1150" b="1" kern="0" spc="200" dirty="0">
+            <a:pPr indent="0" marL="0">
+              <a:buNone/>
+            </a:pPr>
+            <a:r>
+              <a:rPr lang="en-US" sz="1150" b="1" spc="200" kern="0" dirty="0">
                 <a:solidFill>
                   <a:srgbClr val="156082"/>
                 </a:solidFill>
@@ -2524,7 +2732,7 @@
           <a:bodyPr wrap="square" lIns="0" tIns="0" rIns="0" bIns="0" rtlCol="0" anchor="ctr"/>
           <a:lstStyle/>
           <a:p>
-            <a:pPr marL="0" indent="0">
+            <a:pPr indent="0" marL="0">
               <a:buNone/>
             </a:pPr>
             <a:r>
@@ -2563,7 +2771,7 @@
           <a:bodyPr wrap="square" lIns="0" tIns="0" rIns="0" bIns="0" rtlCol="0" anchor="ctr"/>
           <a:lstStyle/>
           <a:p>
-            <a:pPr marL="0" indent="0">
+            <a:pPr indent="0" marL="0">
               <a:buNone/>
             </a:pPr>
             <a:r>
@@ -2607,13 +2815,6 @@
             <a:prstDash val="solid"/>
           </a:ln>
         </p:spPr>
-        <p:txBody>
-          <a:bodyPr/>
-          <a:lstStyle/>
-          <a:p>
-            <a:endParaRPr lang="ja-JP" altLang="en-US"/>
-          </a:p>
-        </p:txBody>
       </p:sp>
       <p:sp>
         <p:nvSpPr>
@@ -2636,7 +2837,7 @@
           <a:bodyPr wrap="square" lIns="0" tIns="0" rIns="0" bIns="0" rtlCol="0" anchor="ctr"/>
           <a:lstStyle/>
           <a:p>
-            <a:pPr marL="0" indent="0">
+            <a:pPr indent="0" marL="0">
               <a:buNone/>
             </a:pPr>
             <a:r>
@@ -2675,7 +2876,7 @@
           <a:bodyPr wrap="square" lIns="0" tIns="0" rIns="0" bIns="0" rtlCol="0" anchor="ctr"/>
           <a:lstStyle/>
           <a:p>
-            <a:pPr marL="0" indent="0">
+            <a:pPr indent="0" marL="0">
               <a:buNone/>
             </a:pPr>
             <a:r>
@@ -2714,7 +2915,7 @@
           <a:bodyPr wrap="square" lIns="0" tIns="0" rIns="0" bIns="0" rtlCol="0" anchor="ctr"/>
           <a:lstStyle/>
           <a:p>
-            <a:pPr marL="0" indent="0">
+            <a:pPr indent="0" marL="0">
               <a:buNone/>
             </a:pPr>
             <a:r>
@@ -2753,7 +2954,7 @@
           <a:bodyPr wrap="square" lIns="0" tIns="0" rIns="0" bIns="0" rtlCol="0" anchor="ctr"/>
           <a:lstStyle/>
           <a:p>
-            <a:pPr marL="0" indent="0">
+            <a:pPr indent="0" marL="0">
               <a:buNone/>
             </a:pPr>
             <a:r>
@@ -2792,7 +2993,7 @@
           <a:bodyPr wrap="square" lIns="0" tIns="0" rIns="0" bIns="0" rtlCol="0" anchor="ctr"/>
           <a:lstStyle/>
           <a:p>
-            <a:pPr marL="0" indent="0">
+            <a:pPr indent="0" marL="0">
               <a:buNone/>
             </a:pPr>
             <a:r>
@@ -2831,7 +3032,7 @@
           <a:bodyPr wrap="square" lIns="0" tIns="0" rIns="0" bIns="0" rtlCol="0" anchor="ctr"/>
           <a:lstStyle/>
           <a:p>
-            <a:pPr marL="0" indent="0">
+            <a:pPr indent="0" marL="0">
               <a:buNone/>
             </a:pPr>
             <a:r>
@@ -2870,7 +3071,7 @@
           <a:bodyPr wrap="square" lIns="0" tIns="0" rIns="0" bIns="0" rtlCol="0" anchor="ctr"/>
           <a:lstStyle/>
           <a:p>
-            <a:pPr marL="0" indent="0">
+            <a:pPr indent="0" marL="0">
               <a:buNone/>
             </a:pPr>
             <a:r>
@@ -2909,7 +3110,7 @@
           <a:bodyPr wrap="square" lIns="0" tIns="0" rIns="0" bIns="0" rtlCol="0" anchor="ctr"/>
           <a:lstStyle/>
           <a:p>
-            <a:pPr marL="0" indent="0">
+            <a:pPr indent="0" marL="0">
               <a:buNone/>
             </a:pPr>
             <a:r>
@@ -2948,7 +3149,7 @@
           <a:bodyPr wrap="square" lIns="0" tIns="0" rIns="0" bIns="0" rtlCol="0" anchor="ctr"/>
           <a:lstStyle/>
           <a:p>
-            <a:pPr marL="0" indent="0">
+            <a:pPr indent="0" marL="0">
               <a:buNone/>
             </a:pPr>
             <a:r>
@@ -2987,7 +3188,7 @@
           <a:bodyPr wrap="square" lIns="0" tIns="0" rIns="0" bIns="0" rtlCol="0" anchor="ctr"/>
           <a:lstStyle/>
           <a:p>
-            <a:pPr marL="0" indent="0">
+            <a:pPr indent="0" marL="0">
               <a:buNone/>
             </a:pPr>
             <a:r>
@@ -3026,7 +3227,7 @@
           <a:bodyPr wrap="square" lIns="0" tIns="0" rIns="0" bIns="0" rtlCol="0" anchor="ctr"/>
           <a:lstStyle/>
           <a:p>
-            <a:pPr marL="0" indent="0">
+            <a:pPr indent="0" marL="0">
               <a:buNone/>
             </a:pPr>
             <a:r>
@@ -3065,7 +3266,7 @@
           <a:bodyPr wrap="square" lIns="0" tIns="0" rIns="0" bIns="0" rtlCol="0" anchor="ctr"/>
           <a:lstStyle/>
           <a:p>
-            <a:pPr marL="0" indent="0">
+            <a:pPr indent="0" marL="0">
               <a:buNone/>
             </a:pPr>
             <a:r>
@@ -3104,7 +3305,7 @@
           <a:bodyPr wrap="square" lIns="0" tIns="0" rIns="0" bIns="0" rtlCol="0" anchor="ctr"/>
           <a:lstStyle/>
           <a:p>
-            <a:pPr marL="0" indent="0">
+            <a:pPr indent="0" marL="0">
               <a:buNone/>
             </a:pPr>
             <a:r>
@@ -3143,7 +3344,7 @@
           <a:bodyPr wrap="square" lIns="0" tIns="0" rIns="0" bIns="0" rtlCol="0" anchor="ctr"/>
           <a:lstStyle/>
           <a:p>
-            <a:pPr marL="0" indent="0">
+            <a:pPr indent="0" marL="0">
               <a:buNone/>
             </a:pPr>
             <a:r>
@@ -3182,7 +3383,7 @@
           <a:bodyPr wrap="square" lIns="0" tIns="0" rIns="0" bIns="0" rtlCol="0" anchor="ctr"/>
           <a:lstStyle/>
           <a:p>
-            <a:pPr marL="0" indent="0">
+            <a:pPr indent="0" marL="0">
               <a:buNone/>
             </a:pPr>
             <a:r>
@@ -3226,13 +3427,6 @@
             <a:prstDash val="solid"/>
           </a:ln>
         </p:spPr>
-        <p:txBody>
-          <a:bodyPr/>
-          <a:lstStyle/>
-          <a:p>
-            <a:endParaRPr lang="ja-JP" altLang="en-US"/>
-          </a:p>
-        </p:txBody>
       </p:sp>
       <p:sp>
         <p:nvSpPr>
@@ -3255,7 +3449,7 @@
           <a:bodyPr wrap="square" lIns="0" tIns="0" rIns="0" bIns="0" rtlCol="0" anchor="ctr"/>
           <a:lstStyle/>
           <a:p>
-            <a:pPr marL="0" indent="0">
+            <a:pPr indent="0" marL="0">
               <a:lnSpc>
                 <a:spcPct val="140000"/>
               </a:lnSpc>
@@ -3275,7 +3469,7 @@
             <a:endParaRPr lang="en-US" sz="1250" dirty="0"/>
           </a:p>
           <a:p>
-            <a:pPr marL="0" indent="0">
+            <a:pPr indent="0" marL="0">
               <a:lnSpc>
                 <a:spcPct val="140000"/>
               </a:lnSpc>
@@ -3295,7 +3489,7 @@
             <a:endParaRPr lang="en-US" sz="1250" dirty="0"/>
           </a:p>
           <a:p>
-            <a:pPr marL="0" indent="0">
+            <a:pPr indent="0" marL="0">
               <a:lnSpc>
                 <a:spcPct val="140000"/>
               </a:lnSpc>
@@ -3315,7 +3509,7 @@
             <a:endParaRPr lang="en-US" sz="1250" dirty="0"/>
           </a:p>
           <a:p>
-            <a:pPr marL="0" indent="0">
+            <a:pPr indent="0" marL="0">
               <a:lnSpc>
                 <a:spcPct val="140000"/>
               </a:lnSpc>
@@ -3357,7 +3551,7 @@
           <a:bodyPr wrap="square" lIns="0" tIns="0" rIns="0" bIns="0" rtlCol="0" anchor="ctr"/>
           <a:lstStyle/>
           <a:p>
-            <a:pPr marL="0" indent="0">
+            <a:pPr indent="0" marL="0">
               <a:lnSpc>
                 <a:spcPct val="130000"/>
               </a:lnSpc>
@@ -3399,7 +3593,7 @@
           <a:bodyPr wrap="square" lIns="0" tIns="0" rIns="0" bIns="0" rtlCol="0" anchor="ctr"/>
           <a:lstStyle/>
           <a:p>
-            <a:pPr marL="0" indent="0">
+            <a:pPr indent="0" marL="0">
               <a:buNone/>
             </a:pPr>
             <a:r>
@@ -3443,13 +3637,6 @@
             <a:prstDash val="solid"/>
           </a:ln>
         </p:spPr>
-        <p:txBody>
-          <a:bodyPr/>
-          <a:lstStyle/>
-          <a:p>
-            <a:endParaRPr lang="ja-JP" altLang="en-US"/>
-          </a:p>
-        </p:txBody>
       </p:sp>
       <p:sp>
         <p:nvSpPr>
@@ -3472,7 +3659,7 @@
           <a:bodyPr wrap="square" lIns="0" tIns="0" rIns="0" bIns="0" rtlCol="0" anchor="ctr"/>
           <a:lstStyle/>
           <a:p>
-            <a:pPr marL="0" indent="0">
+            <a:pPr indent="0" marL="0">
               <a:buNone/>
             </a:pPr>
             <a:r>
@@ -3511,7 +3698,7 @@
           <a:bodyPr wrap="square" lIns="0" tIns="0" rIns="0" bIns="0" rtlCol="0" anchor="ctr"/>
           <a:lstStyle/>
           <a:p>
-            <a:pPr marL="0" indent="0">
+            <a:pPr indent="0" marL="0">
               <a:buNone/>
             </a:pPr>
             <a:r>
@@ -3550,7 +3737,7 @@
           <a:bodyPr wrap="square" lIns="0" tIns="0" rIns="0" bIns="0" rtlCol="0" anchor="ctr"/>
           <a:lstStyle/>
           <a:p>
-            <a:pPr marL="0" indent="0">
+            <a:pPr indent="0" marL="0">
               <a:buNone/>
             </a:pPr>
             <a:r>
@@ -3589,7 +3776,7 @@
           <a:bodyPr wrap="square" lIns="0" tIns="0" rIns="0" bIns="0" rtlCol="0" anchor="ctr"/>
           <a:lstStyle/>
           <a:p>
-            <a:pPr marL="0" indent="0">
+            <a:pPr indent="0" marL="0">
               <a:buNone/>
             </a:pPr>
             <a:r>
@@ -3628,7 +3815,7 @@
           <a:bodyPr wrap="square" lIns="0" tIns="0" rIns="0" bIns="0" rtlCol="0" anchor="ctr"/>
           <a:lstStyle/>
           <a:p>
-            <a:pPr marL="0" indent="0">
+            <a:pPr indent="0" marL="0">
               <a:buNone/>
             </a:pPr>
             <a:r>
@@ -3667,7 +3854,7 @@
           <a:bodyPr wrap="square" lIns="0" tIns="0" rIns="0" bIns="0" rtlCol="0" anchor="ctr"/>
           <a:lstStyle/>
           <a:p>
-            <a:pPr marL="0" indent="0">
+            <a:pPr indent="0" marL="0">
               <a:buNone/>
             </a:pPr>
             <a:r>
@@ -3706,7 +3893,7 @@
           <a:bodyPr wrap="square" lIns="0" tIns="0" rIns="0" bIns="0" rtlCol="0" anchor="ctr"/>
           <a:lstStyle/>
           <a:p>
-            <a:pPr marL="0" indent="0">
+            <a:pPr indent="0" marL="0">
               <a:buNone/>
             </a:pPr>
             <a:r>
@@ -3745,7 +3932,7 @@
           <a:bodyPr wrap="square" lIns="0" tIns="0" rIns="0" bIns="0" rtlCol="0" anchor="ctr"/>
           <a:lstStyle/>
           <a:p>
-            <a:pPr marL="0" indent="0">
+            <a:pPr indent="0" marL="0">
               <a:buNone/>
             </a:pPr>
             <a:r>
@@ -3784,7 +3971,7 @@
           <a:bodyPr wrap="square" lIns="0" tIns="0" rIns="0" bIns="0" rtlCol="0" anchor="ctr"/>
           <a:lstStyle/>
           <a:p>
-            <a:pPr marL="0" indent="0">
+            <a:pPr indent="0" marL="0">
               <a:buNone/>
             </a:pPr>
             <a:r>
@@ -3823,7 +4010,7 @@
           <a:bodyPr wrap="square" lIns="0" tIns="0" rIns="0" bIns="0" rtlCol="0" anchor="ctr"/>
           <a:lstStyle/>
           <a:p>
-            <a:pPr marL="0" indent="0">
+            <a:pPr indent="0" marL="0">
               <a:buNone/>
             </a:pPr>
             <a:r>
@@ -3862,7 +4049,7 @@
           <a:bodyPr wrap="square" lIns="0" tIns="0" rIns="0" bIns="0" rtlCol="0" anchor="ctr"/>
           <a:lstStyle/>
           <a:p>
-            <a:pPr marL="0" indent="0" algn="r">
+            <a:pPr algn="r" indent="0" marL="0">
               <a:buNone/>
             </a:pPr>
             <a:r>
@@ -3896,7 +4083,6 @@
         <a:solidFill>
           <a:srgbClr val="FFFFFF"/>
         </a:solidFill>
-        <a:effectLst/>
       </p:bgPr>
     </p:bg>
     <p:spTree>
@@ -3934,11 +4120,11 @@
           <a:bodyPr wrap="square" lIns="0" tIns="0" rIns="0" bIns="0" rtlCol="0" anchor="ctr"/>
           <a:lstStyle/>
           <a:p>
-            <a:pPr marL="0" indent="0">
-              <a:buNone/>
-            </a:pPr>
-            <a:r>
-              <a:rPr lang="en-US" sz="1150" b="1" kern="0" spc="200" dirty="0">
+            <a:pPr indent="0" marL="0">
+              <a:buNone/>
+            </a:pPr>
+            <a:r>
+              <a:rPr lang="en-US" sz="1150" b="1" spc="200" kern="0" dirty="0">
                 <a:solidFill>
                   <a:srgbClr val="156082"/>
                 </a:solidFill>
@@ -3973,7 +4159,7 @@
           <a:bodyPr wrap="square" lIns="0" tIns="0" rIns="0" bIns="0" rtlCol="0" anchor="ctr"/>
           <a:lstStyle/>
           <a:p>
-            <a:pPr marL="0" indent="0">
+            <a:pPr indent="0" marL="0">
               <a:buNone/>
             </a:pPr>
             <a:r>
@@ -4017,13 +4203,6 @@
             <a:prstDash val="solid"/>
           </a:ln>
         </p:spPr>
-        <p:txBody>
-          <a:bodyPr/>
-          <a:lstStyle/>
-          <a:p>
-            <a:endParaRPr lang="ja-JP" altLang="en-US"/>
-          </a:p>
-        </p:txBody>
       </p:sp>
       <p:sp>
         <p:nvSpPr>
@@ -4046,11 +4225,11 @@
           <a:bodyPr wrap="square" lIns="0" tIns="0" rIns="0" bIns="0" rtlCol="0" anchor="ctr"/>
           <a:lstStyle/>
           <a:p>
-            <a:pPr marL="0" indent="0">
-              <a:buNone/>
-            </a:pPr>
-            <a:r>
-              <a:rPr lang="en-US" sz="1150" b="1" kern="0" spc="150" dirty="0">
+            <a:pPr indent="0" marL="0">
+              <a:buNone/>
+            </a:pPr>
+            <a:r>
+              <a:rPr lang="en-US" sz="1150" b="1" spc="150" kern="0" dirty="0">
                 <a:solidFill>
                   <a:srgbClr val="156082"/>
                 </a:solidFill>
@@ -4085,7 +4264,7 @@
           <a:bodyPr wrap="square" lIns="0" tIns="0" rIns="0" bIns="0" rtlCol="0" anchor="ctr"/>
           <a:lstStyle/>
           <a:p>
-            <a:pPr marL="0" indent="0">
+            <a:pPr indent="0" marL="0">
               <a:buNone/>
             </a:pPr>
             <a:r>
@@ -4124,7 +4303,7 @@
           <a:bodyPr wrap="square" lIns="0" tIns="0" rIns="0" bIns="0" rtlCol="0" anchor="ctr"/>
           <a:lstStyle/>
           <a:p>
-            <a:pPr marL="0" indent="0">
+            <a:pPr indent="0" marL="0">
               <a:lnSpc>
                 <a:spcPct val="130000"/>
               </a:lnSpc>
@@ -4166,7 +4345,7 @@
           <a:bodyPr wrap="square" lIns="0" tIns="0" rIns="0" bIns="0" rtlCol="0" anchor="ctr"/>
           <a:lstStyle/>
           <a:p>
-            <a:pPr marL="0" indent="0">
+            <a:pPr indent="0" marL="0">
               <a:lnSpc>
                 <a:spcPct val="130000"/>
               </a:lnSpc>
@@ -4213,13 +4392,6 @@
             <a:prstDash val="solid"/>
           </a:ln>
         </p:spPr>
-        <p:txBody>
-          <a:bodyPr/>
-          <a:lstStyle/>
-          <a:p>
-            <a:endParaRPr lang="ja-JP" altLang="en-US"/>
-          </a:p>
-        </p:txBody>
       </p:sp>
       <p:sp>
         <p:nvSpPr>
@@ -4242,11 +4414,11 @@
           <a:bodyPr wrap="square" lIns="0" tIns="0" rIns="0" bIns="0" rtlCol="0" anchor="ctr"/>
           <a:lstStyle/>
           <a:p>
-            <a:pPr marL="0" indent="0">
-              <a:buNone/>
-            </a:pPr>
-            <a:r>
-              <a:rPr lang="en-US" sz="1150" b="1" kern="0" spc="150" dirty="0">
+            <a:pPr indent="0" marL="0">
+              <a:buNone/>
+            </a:pPr>
+            <a:r>
+              <a:rPr lang="en-US" sz="1150" b="1" spc="150" kern="0" dirty="0">
                 <a:solidFill>
                   <a:srgbClr val="156082"/>
                 </a:solidFill>
@@ -4281,7 +4453,7 @@
           <a:bodyPr wrap="square" lIns="0" tIns="0" rIns="0" bIns="0" rtlCol="0" anchor="ctr"/>
           <a:lstStyle/>
           <a:p>
-            <a:pPr marL="0" indent="0">
+            <a:pPr indent="0" marL="0">
               <a:buNone/>
             </a:pPr>
             <a:r>
@@ -4320,7 +4492,7 @@
           <a:bodyPr wrap="square" lIns="0" tIns="0" rIns="0" bIns="0" rtlCol="0" anchor="ctr"/>
           <a:lstStyle/>
           <a:p>
-            <a:pPr marL="0" indent="0">
+            <a:pPr indent="0" marL="0">
               <a:lnSpc>
                 <a:spcPct val="130000"/>
               </a:lnSpc>
@@ -4340,7 +4512,7 @@
             <a:endParaRPr lang="en-US" sz="1150" dirty="0"/>
           </a:p>
           <a:p>
-            <a:pPr marL="0" indent="0">
+            <a:pPr indent="0" marL="0">
               <a:lnSpc>
                 <a:spcPct val="130000"/>
               </a:lnSpc>
@@ -4382,7 +4554,7 @@
           <a:bodyPr wrap="square" lIns="0" tIns="0" rIns="0" bIns="0" rtlCol="0" anchor="ctr"/>
           <a:lstStyle/>
           <a:p>
-            <a:pPr marL="0" indent="0">
+            <a:pPr indent="0" marL="0">
               <a:lnSpc>
                 <a:spcPct val="130000"/>
               </a:lnSpc>
@@ -4429,13 +4601,6 @@
             <a:prstDash val="solid"/>
           </a:ln>
         </p:spPr>
-        <p:txBody>
-          <a:bodyPr/>
-          <a:lstStyle/>
-          <a:p>
-            <a:endParaRPr lang="ja-JP" altLang="en-US"/>
-          </a:p>
-        </p:txBody>
       </p:sp>
       <p:sp>
         <p:nvSpPr>
@@ -4458,11 +4623,11 @@
           <a:bodyPr wrap="square" lIns="0" tIns="0" rIns="0" bIns="0" rtlCol="0" anchor="ctr"/>
           <a:lstStyle/>
           <a:p>
-            <a:pPr marL="0" indent="0">
-              <a:buNone/>
-            </a:pPr>
-            <a:r>
-              <a:rPr lang="en-US" sz="1150" b="1" kern="0" spc="150" dirty="0">
+            <a:pPr indent="0" marL="0">
+              <a:buNone/>
+            </a:pPr>
+            <a:r>
+              <a:rPr lang="en-US" sz="1150" b="1" spc="150" kern="0" dirty="0">
                 <a:solidFill>
                   <a:srgbClr val="156082"/>
                 </a:solidFill>
@@ -4497,7 +4662,7 @@
           <a:bodyPr wrap="square" lIns="0" tIns="0" rIns="0" bIns="0" rtlCol="0" anchor="ctr"/>
           <a:lstStyle/>
           <a:p>
-            <a:pPr marL="0" indent="0">
+            <a:pPr indent="0" marL="0">
               <a:buNone/>
             </a:pPr>
             <a:r>
@@ -4536,7 +4701,7 @@
           <a:bodyPr wrap="square" lIns="0" tIns="0" rIns="0" bIns="0" rtlCol="0" anchor="ctr"/>
           <a:lstStyle/>
           <a:p>
-            <a:pPr marL="0" indent="0">
+            <a:pPr indent="0" marL="0">
               <a:lnSpc>
                 <a:spcPct val="130000"/>
               </a:lnSpc>
@@ -4556,7 +4721,7 @@
             <a:endParaRPr lang="en-US" sz="1150" dirty="0"/>
           </a:p>
           <a:p>
-            <a:pPr marL="0" indent="0">
+            <a:pPr indent="0" marL="0">
               <a:lnSpc>
                 <a:spcPct val="130000"/>
               </a:lnSpc>
@@ -4576,7 +4741,7 @@
             <a:endParaRPr lang="en-US" sz="1150" dirty="0"/>
           </a:p>
           <a:p>
-            <a:pPr marL="0" indent="0">
+            <a:pPr indent="0" marL="0">
               <a:lnSpc>
                 <a:spcPct val="130000"/>
               </a:lnSpc>
@@ -4618,7 +4783,7 @@
           <a:bodyPr wrap="square" lIns="0" tIns="0" rIns="0" bIns="0" rtlCol="0" anchor="ctr"/>
           <a:lstStyle/>
           <a:p>
-            <a:pPr marL="0" indent="0">
+            <a:pPr indent="0" marL="0">
               <a:lnSpc>
                 <a:spcPct val="130000"/>
               </a:lnSpc>
@@ -4665,13 +4830,6 @@
             <a:prstDash val="solid"/>
           </a:ln>
         </p:spPr>
-        <p:txBody>
-          <a:bodyPr/>
-          <a:lstStyle/>
-          <a:p>
-            <a:endParaRPr lang="ja-JP" altLang="en-US"/>
-          </a:p>
-        </p:txBody>
       </p:sp>
       <p:sp>
         <p:nvSpPr>
@@ -4694,7 +4852,7 @@
           <a:bodyPr wrap="square" lIns="0" tIns="0" rIns="0" bIns="0" rtlCol="0" anchor="ctr"/>
           <a:lstStyle/>
           <a:p>
-            <a:pPr marL="0" indent="0">
+            <a:pPr indent="0" marL="0">
               <a:buNone/>
             </a:pPr>
             <a:r>
@@ -4733,7 +4891,7 @@
           <a:bodyPr wrap="square" lIns="0" tIns="0" rIns="0" bIns="0" rtlCol="0" anchor="ctr"/>
           <a:lstStyle/>
           <a:p>
-            <a:pPr marL="0" indent="0">
+            <a:pPr indent="0" marL="0">
               <a:lnSpc>
                 <a:spcPct val="140000"/>
               </a:lnSpc>
@@ -4753,7 +4911,7 @@
             <a:endParaRPr lang="en-US" sz="1250" dirty="0"/>
           </a:p>
           <a:p>
-            <a:pPr marL="0" indent="0">
+            <a:pPr indent="0" marL="0">
               <a:lnSpc>
                 <a:spcPct val="140000"/>
               </a:lnSpc>
@@ -4773,7 +4931,7 @@
             <a:endParaRPr lang="en-US" sz="1250" dirty="0"/>
           </a:p>
           <a:p>
-            <a:pPr marL="0" indent="0">
+            <a:pPr indent="0" marL="0">
               <a:lnSpc>
                 <a:spcPct val="140000"/>
               </a:lnSpc>
@@ -4815,7 +4973,7 @@
           <a:bodyPr wrap="square" lIns="0" tIns="0" rIns="0" bIns="0" rtlCol="0" anchor="ctr"/>
           <a:lstStyle/>
           <a:p>
-            <a:pPr marL="0" indent="0" algn="r">
+            <a:pPr algn="r" indent="0" marL="0">
               <a:buNone/>
             </a:pPr>
             <a:r>
@@ -4849,7 +5007,6 @@
         <a:solidFill>
           <a:srgbClr val="FFFFFF"/>
         </a:solidFill>
-        <a:effectLst/>
       </p:bgPr>
     </p:bg>
     <p:spTree>
@@ -4887,11 +5044,11 @@
           <a:bodyPr wrap="square" lIns="0" tIns="0" rIns="0" bIns="0" rtlCol="0" anchor="ctr"/>
           <a:lstStyle/>
           <a:p>
-            <a:pPr marL="0" indent="0">
-              <a:buNone/>
-            </a:pPr>
-            <a:r>
-              <a:rPr lang="en-US" sz="1150" b="1" kern="0" spc="200" dirty="0">
+            <a:pPr indent="0" marL="0">
+              <a:buNone/>
+            </a:pPr>
+            <a:r>
+              <a:rPr lang="en-US" sz="1150" b="1" spc="200" kern="0" dirty="0">
                 <a:solidFill>
                   <a:srgbClr val="156082"/>
                 </a:solidFill>
@@ -4926,7 +5083,7 @@
           <a:bodyPr wrap="square" lIns="0" tIns="0" rIns="0" bIns="0" rtlCol="0" anchor="ctr"/>
           <a:lstStyle/>
           <a:p>
-            <a:pPr marL="0" indent="0">
+            <a:pPr indent="0" marL="0">
               <a:buNone/>
             </a:pPr>
             <a:r>
@@ -4965,7 +5122,7 @@
           <a:bodyPr wrap="square" lIns="0" tIns="0" rIns="0" bIns="0" rtlCol="0" anchor="ctr"/>
           <a:lstStyle/>
           <a:p>
-            <a:pPr marL="0" indent="0">
+            <a:pPr indent="0" marL="0">
               <a:buNone/>
             </a:pPr>
             <a:r>
@@ -5009,13 +5166,6 @@
             <a:prstDash val="solid"/>
           </a:ln>
         </p:spPr>
-        <p:txBody>
-          <a:bodyPr/>
-          <a:lstStyle/>
-          <a:p>
-            <a:endParaRPr lang="ja-JP" altLang="en-US"/>
-          </a:p>
-        </p:txBody>
       </p:sp>
       <p:sp>
         <p:nvSpPr>
@@ -5180,7 +5330,7 @@
           <a:bodyPr wrap="square" lIns="0" tIns="0" rIns="0" bIns="0" rtlCol="0" anchor="ctr"/>
           <a:lstStyle/>
           <a:p>
-            <a:pPr marL="0" indent="0">
+            <a:pPr indent="0" marL="0">
               <a:buNone/>
             </a:pPr>
             <a:r>
@@ -5224,13 +5374,6 @@
             <a:prstDash val="solid"/>
           </a:ln>
         </p:spPr>
-        <p:txBody>
-          <a:bodyPr/>
-          <a:lstStyle/>
-          <a:p>
-            <a:endParaRPr lang="ja-JP" altLang="en-US"/>
-          </a:p>
-        </p:txBody>
       </p:sp>
       <p:sp>
         <p:nvSpPr>
@@ -5253,7 +5396,7 @@
           <a:bodyPr wrap="square" lIns="0" tIns="0" rIns="0" bIns="0" rtlCol="0" anchor="ctr"/>
           <a:lstStyle/>
           <a:p>
-            <a:pPr marL="0" indent="0">
+            <a:pPr indent="0" marL="0">
               <a:buNone/>
             </a:pPr>
             <a:r>
@@ -5292,7 +5435,7 @@
           <a:bodyPr wrap="square" lIns="0" tIns="0" rIns="0" bIns="0" rtlCol="0" anchor="ctr"/>
           <a:lstStyle/>
           <a:p>
-            <a:pPr marL="0" indent="0">
+            <a:pPr indent="0" marL="0">
               <a:buNone/>
             </a:pPr>
             <a:r>
@@ -5331,7 +5474,7 @@
           <a:bodyPr wrap="square" lIns="0" tIns="0" rIns="0" bIns="0" rtlCol="0" anchor="ctr"/>
           <a:lstStyle/>
           <a:p>
-            <a:pPr marL="0" indent="0">
+            <a:pPr indent="0" marL="0">
               <a:buNone/>
             </a:pPr>
             <a:r>
@@ -5370,7 +5513,7 @@
           <a:bodyPr wrap="square" lIns="0" tIns="0" rIns="0" bIns="0" rtlCol="0" anchor="ctr"/>
           <a:lstStyle/>
           <a:p>
-            <a:pPr marL="0" indent="0">
+            <a:pPr indent="0" marL="0">
               <a:buNone/>
             </a:pPr>
             <a:r>
@@ -5409,7 +5552,7 @@
           <a:bodyPr wrap="square" lIns="0" tIns="0" rIns="0" bIns="0" rtlCol="0" anchor="ctr"/>
           <a:lstStyle/>
           <a:p>
-            <a:pPr marL="0" indent="0">
+            <a:pPr indent="0" marL="0">
               <a:buNone/>
             </a:pPr>
             <a:r>
@@ -5448,7 +5591,7 @@
           <a:bodyPr wrap="square" lIns="0" tIns="0" rIns="0" bIns="0" rtlCol="0" anchor="ctr"/>
           <a:lstStyle/>
           <a:p>
-            <a:pPr marL="0" indent="0">
+            <a:pPr indent="0" marL="0">
               <a:buNone/>
             </a:pPr>
             <a:r>
@@ -5487,7 +5630,7 @@
           <a:bodyPr wrap="square" lIns="0" tIns="0" rIns="0" bIns="0" rtlCol="0" anchor="ctr"/>
           <a:lstStyle/>
           <a:p>
-            <a:pPr marL="0" indent="0">
+            <a:pPr indent="0" marL="0">
               <a:buNone/>
             </a:pPr>
             <a:r>
@@ -5526,7 +5669,7 @@
           <a:bodyPr wrap="square" lIns="0" tIns="0" rIns="0" bIns="0" rtlCol="0" anchor="ctr"/>
           <a:lstStyle/>
           <a:p>
-            <a:pPr marL="0" indent="0">
+            <a:pPr indent="0" marL="0">
               <a:buNone/>
             </a:pPr>
             <a:r>
@@ -5570,13 +5713,6 @@
             <a:prstDash val="solid"/>
           </a:ln>
         </p:spPr>
-        <p:txBody>
-          <a:bodyPr/>
-          <a:lstStyle/>
-          <a:p>
-            <a:endParaRPr lang="ja-JP" altLang="en-US"/>
-          </a:p>
-        </p:txBody>
       </p:sp>
       <p:sp>
         <p:nvSpPr>
@@ -5599,7 +5735,7 @@
           <a:bodyPr wrap="square" lIns="0" tIns="0" rIns="0" bIns="0" rtlCol="0" anchor="ctr"/>
           <a:lstStyle/>
           <a:p>
-            <a:pPr marL="0" indent="0">
+            <a:pPr indent="0" marL="0">
               <a:buNone/>
             </a:pPr>
             <a:r>
@@ -5638,7 +5774,7 @@
           <a:bodyPr wrap="square" lIns="0" tIns="0" rIns="0" bIns="0" rtlCol="0" anchor="ctr"/>
           <a:lstStyle/>
           <a:p>
-            <a:pPr marL="0" indent="0" algn="r">
+            <a:pPr algn="r" indent="0" marL="0">
               <a:buNone/>
             </a:pPr>
             <a:r>
@@ -5672,7 +5808,6 @@
         <a:solidFill>
           <a:srgbClr val="FFFFFF"/>
         </a:solidFill>
-        <a:effectLst/>
       </p:bgPr>
     </p:bg>
     <p:spTree>
@@ -5710,11 +5845,11 @@
           <a:bodyPr wrap="square" lIns="0" tIns="0" rIns="0" bIns="0" rtlCol="0" anchor="ctr"/>
           <a:lstStyle/>
           <a:p>
-            <a:pPr marL="0" indent="0">
-              <a:buNone/>
-            </a:pPr>
-            <a:r>
-              <a:rPr lang="en-US" sz="1150" b="1" kern="0" spc="200" dirty="0">
+            <a:pPr indent="0" marL="0">
+              <a:buNone/>
+            </a:pPr>
+            <a:r>
+              <a:rPr lang="en-US" sz="1150" b="1" spc="200" kern="0" dirty="0">
                 <a:solidFill>
                   <a:srgbClr val="156082"/>
                 </a:solidFill>
@@ -5749,7 +5884,7 @@
           <a:bodyPr wrap="square" lIns="0" tIns="0" rIns="0" bIns="0" rtlCol="0" anchor="ctr"/>
           <a:lstStyle/>
           <a:p>
-            <a:pPr marL="0" indent="0">
+            <a:pPr indent="0" marL="0">
               <a:buNone/>
             </a:pPr>
             <a:r>
@@ -5788,7 +5923,7 @@
           <a:bodyPr wrap="square" lIns="0" tIns="0" rIns="0" bIns="0" rtlCol="0" anchor="ctr"/>
           <a:lstStyle/>
           <a:p>
-            <a:pPr marL="0" indent="0">
+            <a:pPr indent="0" marL="0">
               <a:buNone/>
             </a:pPr>
             <a:r>
@@ -5832,13 +5967,6 @@
             <a:prstDash val="solid"/>
           </a:ln>
         </p:spPr>
-        <p:txBody>
-          <a:bodyPr/>
-          <a:lstStyle/>
-          <a:p>
-            <a:endParaRPr lang="ja-JP" altLang="en-US"/>
-          </a:p>
-        </p:txBody>
       </p:sp>
       <p:sp>
         <p:nvSpPr>
@@ -5864,13 +5992,6 @@
             <a:prstDash val="solid"/>
           </a:ln>
         </p:spPr>
-        <p:txBody>
-          <a:bodyPr/>
-          <a:lstStyle/>
-          <a:p>
-            <a:endParaRPr lang="ja-JP" altLang="en-US"/>
-          </a:p>
-        </p:txBody>
       </p:sp>
       <p:sp>
         <p:nvSpPr>
@@ -5893,7 +6014,7 @@
           <a:bodyPr wrap="square" lIns="0" tIns="0" rIns="0" bIns="0" rtlCol="0" anchor="ctr"/>
           <a:lstStyle/>
           <a:p>
-            <a:pPr marL="0" indent="0" algn="ctr">
+            <a:pPr algn="ctr" indent="0" marL="0">
               <a:buNone/>
             </a:pPr>
             <a:r>
@@ -5932,7 +6053,7 @@
           <a:bodyPr wrap="square" lIns="0" tIns="0" rIns="0" bIns="0" rtlCol="0" anchor="ctr"/>
           <a:lstStyle/>
           <a:p>
-            <a:pPr marL="0" indent="0">
+            <a:pPr indent="0" marL="0">
               <a:buNone/>
             </a:pPr>
             <a:r>
@@ -5971,7 +6092,7 @@
           <a:bodyPr wrap="square" lIns="0" tIns="0" rIns="0" bIns="0" rtlCol="0" anchor="ctr"/>
           <a:lstStyle/>
           <a:p>
-            <a:pPr marL="0" indent="0">
+            <a:pPr indent="0" marL="0">
               <a:lnSpc>
                 <a:spcPct val="130000"/>
               </a:lnSpc>
@@ -6018,13 +6139,6 @@
             <a:prstDash val="solid"/>
           </a:ln>
         </p:spPr>
-        <p:txBody>
-          <a:bodyPr/>
-          <a:lstStyle/>
-          <a:p>
-            <a:endParaRPr lang="ja-JP" altLang="en-US"/>
-          </a:p>
-        </p:txBody>
       </p:sp>
       <p:sp>
         <p:nvSpPr>
@@ -6050,13 +6164,6 @@
             <a:prstDash val="solid"/>
           </a:ln>
         </p:spPr>
-        <p:txBody>
-          <a:bodyPr/>
-          <a:lstStyle/>
-          <a:p>
-            <a:endParaRPr lang="ja-JP" altLang="en-US"/>
-          </a:p>
-        </p:txBody>
       </p:sp>
       <p:sp>
         <p:nvSpPr>
@@ -6079,7 +6186,7 @@
           <a:bodyPr wrap="square" lIns="0" tIns="0" rIns="0" bIns="0" rtlCol="0" anchor="ctr"/>
           <a:lstStyle/>
           <a:p>
-            <a:pPr marL="0" indent="0" algn="ctr">
+            <a:pPr algn="ctr" indent="0" marL="0">
               <a:buNone/>
             </a:pPr>
             <a:r>
@@ -6118,7 +6225,7 @@
           <a:bodyPr wrap="square" lIns="0" tIns="0" rIns="0" bIns="0" rtlCol="0" anchor="ctr"/>
           <a:lstStyle/>
           <a:p>
-            <a:pPr marL="0" indent="0">
+            <a:pPr indent="0" marL="0">
               <a:buNone/>
             </a:pPr>
             <a:r>
@@ -6157,7 +6264,7 @@
           <a:bodyPr wrap="square" lIns="0" tIns="0" rIns="0" bIns="0" rtlCol="0" anchor="ctr"/>
           <a:lstStyle/>
           <a:p>
-            <a:pPr marL="0" indent="0">
+            <a:pPr indent="0" marL="0">
               <a:lnSpc>
                 <a:spcPct val="130000"/>
               </a:lnSpc>
@@ -6204,13 +6311,6 @@
             <a:prstDash val="solid"/>
           </a:ln>
         </p:spPr>
-        <p:txBody>
-          <a:bodyPr/>
-          <a:lstStyle/>
-          <a:p>
-            <a:endParaRPr lang="ja-JP" altLang="en-US"/>
-          </a:p>
-        </p:txBody>
       </p:sp>
       <p:sp>
         <p:nvSpPr>
@@ -6236,13 +6336,6 @@
             <a:prstDash val="solid"/>
           </a:ln>
         </p:spPr>
-        <p:txBody>
-          <a:bodyPr/>
-          <a:lstStyle/>
-          <a:p>
-            <a:endParaRPr lang="ja-JP" altLang="en-US"/>
-          </a:p>
-        </p:txBody>
       </p:sp>
       <p:sp>
         <p:nvSpPr>
@@ -6265,7 +6358,7 @@
           <a:bodyPr wrap="square" lIns="0" tIns="0" rIns="0" bIns="0" rtlCol="0" anchor="ctr"/>
           <a:lstStyle/>
           <a:p>
-            <a:pPr marL="0" indent="0" algn="ctr">
+            <a:pPr algn="ctr" indent="0" marL="0">
               <a:buNone/>
             </a:pPr>
             <a:r>
@@ -6304,7 +6397,7 @@
           <a:bodyPr wrap="square" lIns="0" tIns="0" rIns="0" bIns="0" rtlCol="0" anchor="ctr"/>
           <a:lstStyle/>
           <a:p>
-            <a:pPr marL="0" indent="0">
+            <a:pPr indent="0" marL="0">
               <a:buNone/>
             </a:pPr>
             <a:r>
@@ -6343,7 +6436,7 @@
           <a:bodyPr wrap="square" lIns="0" tIns="0" rIns="0" bIns="0" rtlCol="0" anchor="ctr"/>
           <a:lstStyle/>
           <a:p>
-            <a:pPr marL="0" indent="0">
+            <a:pPr indent="0" marL="0">
               <a:lnSpc>
                 <a:spcPct val="130000"/>
               </a:lnSpc>
@@ -6385,7 +6478,7 @@
           <a:bodyPr wrap="square" lIns="0" tIns="0" rIns="0" bIns="0" rtlCol="0" anchor="ctr"/>
           <a:lstStyle/>
           <a:p>
-            <a:pPr marL="0" indent="0">
+            <a:pPr indent="0" marL="0">
               <a:buNone/>
             </a:pPr>
             <a:r>
@@ -6429,13 +6522,6 @@
             <a:prstDash val="solid"/>
           </a:ln>
         </p:spPr>
-        <p:txBody>
-          <a:bodyPr/>
-          <a:lstStyle/>
-          <a:p>
-            <a:endParaRPr lang="ja-JP" altLang="en-US"/>
-          </a:p>
-        </p:txBody>
       </p:sp>
       <p:sp>
         <p:nvSpPr>
@@ -6458,7 +6544,7 @@
           <a:bodyPr wrap="square" lIns="0" tIns="0" rIns="0" bIns="0" rtlCol="0" anchor="ctr"/>
           <a:lstStyle/>
           <a:p>
-            <a:pPr marL="0" indent="0">
+            <a:pPr indent="0" marL="0">
               <a:lnSpc>
                 <a:spcPct val="145000"/>
               </a:lnSpc>
@@ -6478,7 +6564,7 @@
             <a:endParaRPr lang="en-US" sz="1200" dirty="0"/>
           </a:p>
           <a:p>
-            <a:pPr marL="0" indent="0">
+            <a:pPr indent="0" marL="0">
               <a:lnSpc>
                 <a:spcPct val="145000"/>
               </a:lnSpc>
@@ -6498,7 +6584,7 @@
             <a:endParaRPr lang="en-US" sz="1200" dirty="0"/>
           </a:p>
           <a:p>
-            <a:pPr marL="0" indent="0">
+            <a:pPr indent="0" marL="0">
               <a:lnSpc>
                 <a:spcPct val="145000"/>
               </a:lnSpc>
@@ -6518,7 +6604,7 @@
             <a:endParaRPr lang="en-US" sz="1200" dirty="0"/>
           </a:p>
           <a:p>
-            <a:pPr marL="0" indent="0">
+            <a:pPr indent="0" marL="0">
               <a:lnSpc>
                 <a:spcPct val="145000"/>
               </a:lnSpc>
@@ -6538,7 +6624,7 @@
             <a:endParaRPr lang="en-US" sz="1200" dirty="0"/>
           </a:p>
           <a:p>
-            <a:pPr marL="0" indent="0">
+            <a:pPr indent="0" marL="0">
               <a:lnSpc>
                 <a:spcPct val="145000"/>
               </a:lnSpc>
@@ -6580,7 +6666,7 @@
           <a:bodyPr wrap="square" lIns="0" tIns="0" rIns="0" bIns="0" rtlCol="0" anchor="ctr"/>
           <a:lstStyle/>
           <a:p>
-            <a:pPr marL="0" indent="0">
+            <a:pPr indent="0" marL="0">
               <a:buNone/>
             </a:pPr>
             <a:r>
@@ -6624,13 +6710,6 @@
             <a:prstDash val="solid"/>
           </a:ln>
         </p:spPr>
-        <p:txBody>
-          <a:bodyPr/>
-          <a:lstStyle/>
-          <a:p>
-            <a:endParaRPr lang="ja-JP" altLang="en-US"/>
-          </a:p>
-        </p:txBody>
       </p:sp>
       <p:sp>
         <p:nvSpPr>
@@ -6723,7 +6802,7 @@
           <a:bodyPr wrap="square" lIns="0" tIns="0" rIns="0" bIns="0" rtlCol="0" anchor="ctr"/>
           <a:lstStyle/>
           <a:p>
-            <a:pPr marL="0" indent="0" algn="r">
+            <a:pPr algn="r" indent="0" marL="0">
               <a:buNone/>
             </a:pPr>
             <a:r>
@@ -6757,7 +6836,6 @@
         <a:solidFill>
           <a:srgbClr val="FFFFFF"/>
         </a:solidFill>
-        <a:effectLst/>
       </p:bgPr>
     </p:bg>
     <p:spTree>
@@ -6795,11 +6873,11 @@
           <a:bodyPr wrap="square" lIns="0" tIns="0" rIns="0" bIns="0" rtlCol="0" anchor="ctr"/>
           <a:lstStyle/>
           <a:p>
-            <a:pPr marL="0" indent="0">
-              <a:buNone/>
-            </a:pPr>
-            <a:r>
-              <a:rPr lang="en-US" sz="1150" b="1" kern="0" spc="200" dirty="0">
+            <a:pPr indent="0" marL="0">
+              <a:buNone/>
+            </a:pPr>
+            <a:r>
+              <a:rPr lang="en-US" sz="1150" b="1" spc="200" kern="0" dirty="0">
                 <a:solidFill>
                   <a:srgbClr val="156082"/>
                 </a:solidFill>
@@ -6834,7 +6912,7 @@
           <a:bodyPr wrap="square" lIns="0" tIns="0" rIns="0" bIns="0" rtlCol="0" anchor="ctr"/>
           <a:lstStyle/>
           <a:p>
-            <a:pPr marL="0" indent="0">
+            <a:pPr indent="0" marL="0">
               <a:buNone/>
             </a:pPr>
             <a:r>
@@ -6873,7 +6951,7 @@
           <a:bodyPr wrap="square" lIns="0" tIns="0" rIns="0" bIns="0" rtlCol="0" anchor="ctr"/>
           <a:lstStyle/>
           <a:p>
-            <a:pPr marL="0" indent="0">
+            <a:pPr indent="0" marL="0">
               <a:buNone/>
             </a:pPr>
             <a:r>
@@ -6917,13 +6995,6 @@
             <a:prstDash val="solid"/>
           </a:ln>
         </p:spPr>
-        <p:txBody>
-          <a:bodyPr/>
-          <a:lstStyle/>
-          <a:p>
-            <a:endParaRPr lang="ja-JP" altLang="en-US"/>
-          </a:p>
-        </p:txBody>
       </p:sp>
       <p:sp>
         <p:nvSpPr>
@@ -7112,7 +7183,7 @@
           <a:bodyPr wrap="square" lIns="0" tIns="0" rIns="0" bIns="0" rtlCol="0" anchor="ctr"/>
           <a:lstStyle/>
           <a:p>
-            <a:pPr marL="0" indent="0">
+            <a:pPr indent="0" marL="0">
               <a:buNone/>
             </a:pPr>
             <a:r>
@@ -7156,13 +7227,6 @@
             <a:prstDash val="solid"/>
           </a:ln>
         </p:spPr>
-        <p:txBody>
-          <a:bodyPr/>
-          <a:lstStyle/>
-          <a:p>
-            <a:endParaRPr lang="ja-JP" altLang="en-US"/>
-          </a:p>
-        </p:txBody>
       </p:sp>
       <p:sp>
         <p:nvSpPr>
@@ -7279,7 +7343,7 @@
           <a:bodyPr wrap="square" lIns="0" tIns="0" rIns="0" bIns="0" rtlCol="0" anchor="ctr"/>
           <a:lstStyle/>
           <a:p>
-            <a:pPr marL="0" indent="0">
+            <a:pPr indent="0" marL="0">
               <a:lnSpc>
                 <a:spcPct val="135000"/>
               </a:lnSpc>
@@ -7326,13 +7390,6 @@
             <a:prstDash val="solid"/>
           </a:ln>
         </p:spPr>
-        <p:txBody>
-          <a:bodyPr/>
-          <a:lstStyle/>
-          <a:p>
-            <a:endParaRPr lang="ja-JP" altLang="en-US"/>
-          </a:p>
-        </p:txBody>
       </p:sp>
       <p:sp>
         <p:nvSpPr>
@@ -7355,7 +7412,7 @@
           <a:bodyPr wrap="square" lIns="0" tIns="0" rIns="0" bIns="0" rtlCol="0" anchor="ctr"/>
           <a:lstStyle/>
           <a:p>
-            <a:pPr marL="0" indent="0">
+            <a:pPr indent="0" marL="0">
               <a:buNone/>
             </a:pPr>
             <a:r>
@@ -7394,7 +7451,7 @@
           <a:bodyPr wrap="square" lIns="0" tIns="0" rIns="0" bIns="0" rtlCol="0" anchor="ctr"/>
           <a:lstStyle/>
           <a:p>
-            <a:pPr marL="0" indent="0">
+            <a:pPr indent="0" marL="0">
               <a:lnSpc>
                 <a:spcPct val="138000"/>
               </a:lnSpc>
@@ -7414,7 +7471,7 @@
             <a:endParaRPr lang="en-US" sz="1250" dirty="0"/>
           </a:p>
           <a:p>
-            <a:pPr marL="0" indent="0">
+            <a:pPr indent="0" marL="0">
               <a:lnSpc>
                 <a:spcPct val="138000"/>
               </a:lnSpc>
@@ -7456,7 +7513,7 @@
           <a:bodyPr wrap="square" lIns="0" tIns="0" rIns="0" bIns="0" rtlCol="0" anchor="ctr"/>
           <a:lstStyle/>
           <a:p>
-            <a:pPr marL="0" indent="0" algn="r">
+            <a:pPr algn="r" indent="0" marL="0">
               <a:buNone/>
             </a:pPr>
             <a:r>
@@ -7490,7 +7547,6 @@
         <a:solidFill>
           <a:srgbClr val="FFFFFF"/>
         </a:solidFill>
-        <a:effectLst/>
       </p:bgPr>
     </p:bg>
     <p:spTree>
@@ -7528,11 +7584,11 @@
           <a:bodyPr wrap="square" lIns="0" tIns="0" rIns="0" bIns="0" rtlCol="0" anchor="ctr"/>
           <a:lstStyle/>
           <a:p>
-            <a:pPr marL="0" indent="0">
-              <a:buNone/>
-            </a:pPr>
-            <a:r>
-              <a:rPr lang="en-US" sz="1150" b="1" kern="0" spc="200" dirty="0">
+            <a:pPr indent="0" marL="0">
+              <a:buNone/>
+            </a:pPr>
+            <a:r>
+              <a:rPr lang="en-US" sz="1150" b="1" spc="200" kern="0" dirty="0">
                 <a:solidFill>
                   <a:srgbClr val="156082"/>
                 </a:solidFill>
@@ -7567,7 +7623,7 @@
           <a:bodyPr wrap="square" lIns="0" tIns="0" rIns="0" bIns="0" rtlCol="0" anchor="ctr"/>
           <a:lstStyle/>
           <a:p>
-            <a:pPr marL="0" indent="0">
+            <a:pPr indent="0" marL="0">
               <a:buNone/>
             </a:pPr>
             <a:r>
@@ -7611,13 +7667,6 @@
             <a:prstDash val="solid"/>
           </a:ln>
         </p:spPr>
-        <p:txBody>
-          <a:bodyPr/>
-          <a:lstStyle/>
-          <a:p>
-            <a:endParaRPr lang="ja-JP" altLang="en-US"/>
-          </a:p>
-        </p:txBody>
       </p:sp>
       <p:sp>
         <p:nvSpPr>
@@ -7643,13 +7692,6 @@
             <a:prstDash val="solid"/>
           </a:ln>
         </p:spPr>
-        <p:txBody>
-          <a:bodyPr/>
-          <a:lstStyle/>
-          <a:p>
-            <a:endParaRPr lang="ja-JP" altLang="en-US"/>
-          </a:p>
-        </p:txBody>
       </p:sp>
       <p:sp>
         <p:nvSpPr>
@@ -7672,7 +7714,7 @@
           <a:bodyPr wrap="square" lIns="0" tIns="0" rIns="0" bIns="0" rtlCol="0" anchor="ctr"/>
           <a:lstStyle/>
           <a:p>
-            <a:pPr marL="0" indent="0" algn="ctr">
+            <a:pPr algn="ctr" indent="0" marL="0">
               <a:buNone/>
             </a:pPr>
             <a:r>
@@ -7711,7 +7753,7 @@
           <a:bodyPr wrap="square" lIns="0" tIns="0" rIns="0" bIns="0" rtlCol="0" anchor="ctr"/>
           <a:lstStyle/>
           <a:p>
-            <a:pPr marL="0" indent="0">
+            <a:pPr indent="0" marL="0">
               <a:buNone/>
             </a:pPr>
             <a:r>
@@ -7750,7 +7792,7 @@
           <a:bodyPr wrap="square" lIns="0" tIns="0" rIns="0" bIns="0" rtlCol="0" anchor="ctr"/>
           <a:lstStyle/>
           <a:p>
-            <a:pPr marL="0" indent="0">
+            <a:pPr indent="0" marL="0">
               <a:lnSpc>
                 <a:spcPct val="135000"/>
               </a:lnSpc>
@@ -7795,13 +7837,6 @@
             <a:prstDash val="solid"/>
           </a:ln>
         </p:spPr>
-        <p:txBody>
-          <a:bodyPr/>
-          <a:lstStyle/>
-          <a:p>
-            <a:endParaRPr lang="ja-JP" altLang="en-US"/>
-          </a:p>
-        </p:txBody>
       </p:sp>
       <p:sp>
         <p:nvSpPr>
@@ -7829,13 +7864,6 @@
             <a:prstDash val="solid"/>
           </a:ln>
         </p:spPr>
-        <p:txBody>
-          <a:bodyPr/>
-          <a:lstStyle/>
-          <a:p>
-            <a:endParaRPr lang="ja-JP" altLang="en-US"/>
-          </a:p>
-        </p:txBody>
       </p:sp>
       <p:sp>
         <p:nvSpPr>
@@ -7861,13 +7889,6 @@
             <a:prstDash val="solid"/>
           </a:ln>
         </p:spPr>
-        <p:txBody>
-          <a:bodyPr/>
-          <a:lstStyle/>
-          <a:p>
-            <a:endParaRPr lang="ja-JP" altLang="en-US"/>
-          </a:p>
-        </p:txBody>
       </p:sp>
       <p:sp>
         <p:nvSpPr>
@@ -7890,7 +7911,7 @@
           <a:bodyPr wrap="square" lIns="0" tIns="0" rIns="0" bIns="0" rtlCol="0" anchor="ctr"/>
           <a:lstStyle/>
           <a:p>
-            <a:pPr marL="0" indent="0" algn="ctr">
+            <a:pPr algn="ctr" indent="0" marL="0">
               <a:buNone/>
             </a:pPr>
             <a:r>
@@ -7929,7 +7950,7 @@
           <a:bodyPr wrap="square" lIns="0" tIns="0" rIns="0" bIns="0" rtlCol="0" anchor="ctr"/>
           <a:lstStyle/>
           <a:p>
-            <a:pPr marL="0" indent="0">
+            <a:pPr indent="0" marL="0">
               <a:buNone/>
             </a:pPr>
             <a:r>
@@ -7968,7 +7989,7 @@
           <a:bodyPr wrap="square" lIns="0" tIns="0" rIns="0" bIns="0" rtlCol="0" anchor="ctr"/>
           <a:lstStyle/>
           <a:p>
-            <a:pPr marL="0" indent="0">
+            <a:pPr indent="0" marL="0">
               <a:lnSpc>
                 <a:spcPct val="135000"/>
               </a:lnSpc>
@@ -8013,13 +8034,6 @@
             <a:prstDash val="solid"/>
           </a:ln>
         </p:spPr>
-        <p:txBody>
-          <a:bodyPr/>
-          <a:lstStyle/>
-          <a:p>
-            <a:endParaRPr lang="ja-JP" altLang="en-US"/>
-          </a:p>
-        </p:txBody>
       </p:sp>
       <p:sp>
         <p:nvSpPr>
@@ -8047,13 +8061,6 @@
             <a:prstDash val="solid"/>
           </a:ln>
         </p:spPr>
-        <p:txBody>
-          <a:bodyPr/>
-          <a:lstStyle/>
-          <a:p>
-            <a:endParaRPr lang="ja-JP" altLang="en-US"/>
-          </a:p>
-        </p:txBody>
       </p:sp>
       <p:sp>
         <p:nvSpPr>
@@ -8079,13 +8086,6 @@
             <a:prstDash val="solid"/>
           </a:ln>
         </p:spPr>
-        <p:txBody>
-          <a:bodyPr/>
-          <a:lstStyle/>
-          <a:p>
-            <a:endParaRPr lang="ja-JP" altLang="en-US"/>
-          </a:p>
-        </p:txBody>
       </p:sp>
       <p:sp>
         <p:nvSpPr>
@@ -8108,7 +8108,7 @@
           <a:bodyPr wrap="square" lIns="0" tIns="0" rIns="0" bIns="0" rtlCol="0" anchor="ctr"/>
           <a:lstStyle/>
           <a:p>
-            <a:pPr marL="0" indent="0" algn="ctr">
+            <a:pPr algn="ctr" indent="0" marL="0">
               <a:buNone/>
             </a:pPr>
             <a:r>
@@ -8147,7 +8147,7 @@
           <a:bodyPr wrap="square" lIns="0" tIns="0" rIns="0" bIns="0" rtlCol="0" anchor="ctr"/>
           <a:lstStyle/>
           <a:p>
-            <a:pPr marL="0" indent="0">
+            <a:pPr indent="0" marL="0">
               <a:buNone/>
             </a:pPr>
             <a:r>
@@ -8186,7 +8186,7 @@
           <a:bodyPr wrap="square" lIns="0" tIns="0" rIns="0" bIns="0" rtlCol="0" anchor="ctr"/>
           <a:lstStyle/>
           <a:p>
-            <a:pPr marL="0" indent="0">
+            <a:pPr indent="0" marL="0">
               <a:lnSpc>
                 <a:spcPct val="135000"/>
               </a:lnSpc>
@@ -8228,7 +8228,7 @@
           <a:bodyPr wrap="square" lIns="0" tIns="0" rIns="0" bIns="0" rtlCol="0" anchor="ctr"/>
           <a:lstStyle/>
           <a:p>
-            <a:pPr marL="0" indent="0">
+            <a:pPr indent="0" marL="0">
               <a:buNone/>
             </a:pPr>
             <a:r>
@@ -8272,13 +8272,6 @@
             <a:prstDash val="solid"/>
           </a:ln>
         </p:spPr>
-        <p:txBody>
-          <a:bodyPr/>
-          <a:lstStyle/>
-          <a:p>
-            <a:endParaRPr lang="ja-JP" altLang="en-US"/>
-          </a:p>
-        </p:txBody>
       </p:sp>
       <p:sp>
         <p:nvSpPr>
@@ -8371,7 +8364,7 @@
           <a:bodyPr wrap="square" lIns="0" tIns="0" rIns="0" bIns="0" rtlCol="0" anchor="ctr"/>
           <a:lstStyle/>
           <a:p>
-            <a:pPr marL="0" indent="0">
+            <a:pPr indent="0" marL="0">
               <a:buNone/>
             </a:pPr>
             <a:r>
@@ -8415,13 +8408,6 @@
             <a:prstDash val="solid"/>
           </a:ln>
         </p:spPr>
-        <p:txBody>
-          <a:bodyPr/>
-          <a:lstStyle/>
-          <a:p>
-            <a:endParaRPr lang="ja-JP" altLang="en-US"/>
-          </a:p>
-        </p:txBody>
       </p:sp>
       <p:sp>
         <p:nvSpPr>
@@ -8514,7 +8500,7 @@
           <a:bodyPr wrap="square" lIns="0" tIns="0" rIns="0" bIns="0" rtlCol="0" anchor="ctr"/>
           <a:lstStyle/>
           <a:p>
-            <a:pPr marL="0" indent="0" algn="r">
+            <a:pPr algn="r" indent="0" marL="0">
               <a:buNone/>
             </a:pPr>
             <a:r>
@@ -8548,7 +8534,6 @@
         <a:solidFill>
           <a:srgbClr val="FFFFFF"/>
         </a:solidFill>
-        <a:effectLst/>
       </p:bgPr>
     </p:bg>
     <p:spTree>
@@ -8586,7 +8571,7 @@
           <a:bodyPr wrap="square" lIns="0" tIns="0" rIns="0" bIns="0" rtlCol="0" anchor="ctr"/>
           <a:lstStyle/>
           <a:p>
-            <a:pPr marL="0" indent="0">
+            <a:pPr indent="0" marL="0">
               <a:buNone/>
             </a:pPr>
             <a:r>
@@ -8628,13 +8613,6 @@
             <a:prstDash val="solid"/>
           </a:ln>
         </p:spPr>
-        <p:txBody>
-          <a:bodyPr/>
-          <a:lstStyle/>
-          <a:p>
-            <a:endParaRPr lang="ja-JP" altLang="en-US"/>
-          </a:p>
-        </p:txBody>
       </p:sp>
       <p:sp>
         <p:nvSpPr>
@@ -8657,7 +8635,7 @@
           <a:bodyPr wrap="square" lIns="0" tIns="0" rIns="0" bIns="0" rtlCol="0" anchor="ctr"/>
           <a:lstStyle/>
           <a:p>
-            <a:pPr marL="0" indent="0" algn="ctr">
+            <a:pPr algn="ctr" indent="0" marL="0">
               <a:buNone/>
             </a:pPr>
             <a:r>
@@ -8696,7 +8674,7 @@
           <a:bodyPr wrap="square" lIns="0" tIns="0" rIns="0" bIns="0" rtlCol="0" anchor="ctr"/>
           <a:lstStyle/>
           <a:p>
-            <a:pPr marL="0" indent="0">
+            <a:pPr indent="0" marL="0">
               <a:buNone/>
             </a:pPr>
             <a:r>
@@ -8738,13 +8716,6 @@
             <a:prstDash val="solid"/>
           </a:ln>
         </p:spPr>
-        <p:txBody>
-          <a:bodyPr/>
-          <a:lstStyle/>
-          <a:p>
-            <a:endParaRPr lang="ja-JP" altLang="en-US"/>
-          </a:p>
-        </p:txBody>
       </p:sp>
       <p:sp>
         <p:nvSpPr>
@@ -8767,7 +8738,7 @@
           <a:bodyPr wrap="square" lIns="0" tIns="0" rIns="0" bIns="0" rtlCol="0" anchor="ctr"/>
           <a:lstStyle/>
           <a:p>
-            <a:pPr marL="0" indent="0" algn="ctr">
+            <a:pPr algn="ctr" indent="0" marL="0">
               <a:buNone/>
             </a:pPr>
             <a:r>
@@ -8806,7 +8777,7 @@
           <a:bodyPr wrap="square" lIns="0" tIns="0" rIns="0" bIns="0" rtlCol="0" anchor="ctr"/>
           <a:lstStyle/>
           <a:p>
-            <a:pPr marL="0" indent="0">
+            <a:pPr indent="0" marL="0">
               <a:buNone/>
             </a:pPr>
             <a:r>
@@ -8845,7 +8816,7 @@
           <a:bodyPr wrap="square" lIns="0" tIns="0" rIns="0" bIns="0" rtlCol="0" anchor="ctr"/>
           <a:lstStyle/>
           <a:p>
-            <a:pPr marL="0" indent="0">
+            <a:pPr indent="0" marL="0">
               <a:buNone/>
             </a:pPr>
             <a:r>
@@ -8884,7 +8855,7 @@
           <a:bodyPr wrap="square" lIns="0" tIns="0" rIns="0" bIns="0" rtlCol="0" anchor="ctr"/>
           <a:lstStyle/>
           <a:p>
-            <a:pPr marL="0" indent="0">
+            <a:pPr indent="0" marL="0">
               <a:buNone/>
             </a:pPr>
             <a:r>
@@ -8923,7 +8894,7 @@
           <a:bodyPr wrap="square" lIns="0" tIns="0" rIns="0" bIns="0" rtlCol="0" anchor="ctr"/>
           <a:lstStyle/>
           <a:p>
-            <a:pPr marL="0" indent="0">
+            <a:pPr indent="0" marL="0">
               <a:buNone/>
             </a:pPr>
             <a:r>
@@ -8962,7 +8933,7 @@
           <a:bodyPr wrap="square" lIns="0" tIns="0" rIns="0" bIns="0" rtlCol="0" anchor="ctr"/>
           <a:lstStyle/>
           <a:p>
-            <a:pPr marL="0" indent="0">
+            <a:pPr indent="0" marL="0">
               <a:buNone/>
             </a:pPr>
             <a:r>
@@ -9004,13 +8975,6 @@
             <a:prstDash val="solid"/>
           </a:ln>
         </p:spPr>
-        <p:txBody>
-          <a:bodyPr/>
-          <a:lstStyle/>
-          <a:p>
-            <a:endParaRPr lang="ja-JP" altLang="en-US"/>
-          </a:p>
-        </p:txBody>
       </p:sp>
       <p:sp>
         <p:nvSpPr>
@@ -9033,7 +8997,7 @@
           <a:bodyPr wrap="square" lIns="0" tIns="0" rIns="0" bIns="0" rtlCol="0" anchor="ctr"/>
           <a:lstStyle/>
           <a:p>
-            <a:pPr marL="0" indent="0" algn="ctr">
+            <a:pPr algn="ctr" indent="0" marL="0">
               <a:buNone/>
             </a:pPr>
             <a:r>
@@ -9072,7 +9036,7 @@
           <a:bodyPr wrap="square" lIns="0" tIns="0" rIns="0" bIns="0" rtlCol="0" anchor="ctr"/>
           <a:lstStyle/>
           <a:p>
-            <a:pPr marL="0" indent="0">
+            <a:pPr indent="0" marL="0">
               <a:buNone/>
             </a:pPr>
             <a:r>
@@ -9114,13 +9078,6 @@
             <a:prstDash val="solid"/>
           </a:ln>
         </p:spPr>
-        <p:txBody>
-          <a:bodyPr/>
-          <a:lstStyle/>
-          <a:p>
-            <a:endParaRPr lang="ja-JP" altLang="en-US"/>
-          </a:p>
-        </p:txBody>
       </p:sp>
       <p:sp>
         <p:nvSpPr>
@@ -9143,7 +9100,7 @@
           <a:bodyPr wrap="square" lIns="0" tIns="0" rIns="0" bIns="0" rtlCol="0" anchor="ctr"/>
           <a:lstStyle/>
           <a:p>
-            <a:pPr marL="0" indent="0" algn="ctr">
+            <a:pPr algn="ctr" indent="0" marL="0">
               <a:buNone/>
             </a:pPr>
             <a:r>
@@ -9182,7 +9139,7 @@
           <a:bodyPr wrap="square" lIns="0" tIns="0" rIns="0" bIns="0" rtlCol="0" anchor="ctr"/>
           <a:lstStyle/>
           <a:p>
-            <a:pPr marL="0" indent="0">
+            <a:pPr indent="0" marL="0">
               <a:buNone/>
             </a:pPr>
             <a:r>
@@ -9221,7 +9178,7 @@
           <a:bodyPr wrap="square" lIns="0" tIns="0" rIns="0" bIns="0" rtlCol="0" anchor="ctr"/>
           <a:lstStyle/>
           <a:p>
-            <a:pPr marL="0" indent="0">
+            <a:pPr indent="0" marL="0">
               <a:buNone/>
             </a:pPr>
             <a:r>
@@ -9260,7 +9217,7 @@
           <a:bodyPr wrap="square" lIns="0" tIns="0" rIns="0" bIns="0" rtlCol="0" anchor="ctr"/>
           <a:lstStyle/>
           <a:p>
-            <a:pPr marL="0" indent="0" algn="r">
+            <a:pPr algn="r" indent="0" marL="0">
               <a:buNone/>
             </a:pPr>
             <a:r>
@@ -9294,7 +9251,6 @@
         <a:solidFill>
           <a:srgbClr val="FFFFFF"/>
         </a:solidFill>
-        <a:effectLst/>
       </p:bgPr>
     </p:bg>
     <p:spTree>
@@ -9332,7 +9288,7 @@
           <a:bodyPr wrap="square" lIns="0" tIns="0" rIns="0" bIns="0" rtlCol="0" anchor="ctr"/>
           <a:lstStyle/>
           <a:p>
-            <a:pPr marL="0" indent="0">
+            <a:pPr indent="0" marL="0">
               <a:buNone/>
             </a:pPr>
             <a:r>
@@ -9376,20 +9332,13 @@
             <a:prstDash val="solid"/>
           </a:ln>
           <a:effectLst>
-            <a:outerShdw blurRad="127000" dist="25400" dir="5400000" algn="bl" rotWithShape="0">
+            <a:outerShdw sx="100000" sy="100000" kx="0" ky="0" algn="bl" rotWithShape="0" blurRad="127000" dist="25400" dir="5400000">
               <a:srgbClr val="9AA8B4">
                 <a:alpha val="20000"/>
               </a:srgbClr>
             </a:outerShdw>
           </a:effectLst>
         </p:spPr>
-        <p:txBody>
-          <a:bodyPr/>
-          <a:lstStyle/>
-          <a:p>
-            <a:endParaRPr lang="ja-JP" altLang="en-US"/>
-          </a:p>
-        </p:txBody>
       </p:sp>
       <p:sp>
         <p:nvSpPr>
@@ -9417,13 +9366,6 @@
             <a:prstDash val="solid"/>
           </a:ln>
         </p:spPr>
-        <p:txBody>
-          <a:bodyPr/>
-          <a:lstStyle/>
-          <a:p>
-            <a:endParaRPr lang="ja-JP" altLang="en-US"/>
-          </a:p>
-        </p:txBody>
       </p:sp>
       <p:sp>
         <p:nvSpPr>
@@ -9446,7 +9388,7 @@
           <a:bodyPr wrap="square" lIns="0" tIns="0" rIns="0" bIns="0" rtlCol="0" anchor="ctr"/>
           <a:lstStyle/>
           <a:p>
-            <a:pPr marL="0" indent="0" algn="ctr">
+            <a:pPr algn="ctr" indent="0" marL="0">
               <a:buNone/>
             </a:pPr>
             <a:r>
@@ -9485,7 +9427,7 @@
           <a:bodyPr wrap="square" lIns="0" tIns="0" rIns="0" bIns="0" rtlCol="0" anchor="ctr"/>
           <a:lstStyle/>
           <a:p>
-            <a:pPr marL="0" indent="0">
+            <a:pPr indent="0" marL="0">
               <a:lnSpc>
                 <a:spcPct val="120000"/>
               </a:lnSpc>
@@ -9505,7 +9447,7 @@
             <a:endParaRPr lang="en-US" sz="1800" dirty="0"/>
           </a:p>
           <a:p>
-            <a:pPr marL="0" indent="0">
+            <a:pPr indent="0" marL="0">
               <a:lnSpc>
                 <a:spcPct val="120000"/>
               </a:lnSpc>
@@ -9622,20 +9564,13 @@
             <a:prstDash val="solid"/>
           </a:ln>
           <a:effectLst>
-            <a:outerShdw blurRad="127000" dist="25400" dir="5400000" algn="bl" rotWithShape="0">
+            <a:outerShdw sx="100000" sy="100000" kx="0" ky="0" algn="bl" rotWithShape="0" blurRad="127000" dist="25400" dir="5400000">
               <a:srgbClr val="9AA8B4">
                 <a:alpha val="20000"/>
               </a:srgbClr>
             </a:outerShdw>
           </a:effectLst>
         </p:spPr>
-        <p:txBody>
-          <a:bodyPr/>
-          <a:lstStyle/>
-          <a:p>
-            <a:endParaRPr lang="ja-JP" altLang="en-US"/>
-          </a:p>
-        </p:txBody>
       </p:sp>
       <p:sp>
         <p:nvSpPr>
@@ -9663,13 +9598,6 @@
             <a:prstDash val="solid"/>
           </a:ln>
         </p:spPr>
-        <p:txBody>
-          <a:bodyPr/>
-          <a:lstStyle/>
-          <a:p>
-            <a:endParaRPr lang="ja-JP" altLang="en-US"/>
-          </a:p>
-        </p:txBody>
       </p:sp>
       <p:sp>
         <p:nvSpPr>
@@ -9692,7 +9620,7 @@
           <a:bodyPr wrap="square" lIns="0" tIns="0" rIns="0" bIns="0" rtlCol="0" anchor="ctr"/>
           <a:lstStyle/>
           <a:p>
-            <a:pPr marL="0" indent="0" algn="ctr">
+            <a:pPr algn="ctr" indent="0" marL="0">
               <a:buNone/>
             </a:pPr>
             <a:r>
@@ -9731,7 +9659,7 @@
           <a:bodyPr wrap="square" lIns="0" tIns="0" rIns="0" bIns="0" rtlCol="0" anchor="ctr"/>
           <a:lstStyle/>
           <a:p>
-            <a:pPr marL="0" indent="0">
+            <a:pPr indent="0" marL="0">
               <a:lnSpc>
                 <a:spcPct val="120000"/>
               </a:lnSpc>
@@ -9751,7 +9679,7 @@
             <a:endParaRPr lang="en-US" sz="1800" dirty="0"/>
           </a:p>
           <a:p>
-            <a:pPr marL="0" indent="0">
+            <a:pPr indent="0" marL="0">
               <a:lnSpc>
                 <a:spcPct val="120000"/>
               </a:lnSpc>
@@ -9866,13 +9794,6 @@
             <a:prstDash val="solid"/>
           </a:ln>
         </p:spPr>
-        <p:txBody>
-          <a:bodyPr/>
-          <a:lstStyle/>
-          <a:p>
-            <a:endParaRPr lang="ja-JP" altLang="en-US"/>
-          </a:p>
-        </p:txBody>
       </p:sp>
       <p:sp>
         <p:nvSpPr>
@@ -9900,13 +9821,6 @@
             <a:prstDash val="solid"/>
           </a:ln>
         </p:spPr>
-        <p:txBody>
-          <a:bodyPr/>
-          <a:lstStyle/>
-          <a:p>
-            <a:endParaRPr lang="ja-JP" altLang="en-US"/>
-          </a:p>
-        </p:txBody>
       </p:sp>
       <p:sp>
         <p:nvSpPr>
@@ -9929,7 +9843,7 @@
           <a:bodyPr wrap="square" lIns="0" tIns="0" rIns="0" bIns="0" rtlCol="0" anchor="ctr"/>
           <a:lstStyle/>
           <a:p>
-            <a:pPr marL="0" indent="0">
+            <a:pPr indent="0" marL="0">
               <a:buNone/>
             </a:pPr>
             <a:r>
@@ -9968,7 +9882,7 @@
           <a:bodyPr wrap="square" lIns="0" tIns="0" rIns="0" bIns="0" rtlCol="0" anchor="ctr"/>
           <a:lstStyle/>
           <a:p>
-            <a:pPr marL="0" indent="0">
+            <a:pPr indent="0" marL="0">
               <a:buNone/>
             </a:pPr>
             <a:r>
@@ -10007,7 +9921,7 @@
           <a:bodyPr wrap="square" lIns="0" tIns="0" rIns="0" bIns="0" rtlCol="0" anchor="ctr"/>
           <a:lstStyle/>
           <a:p>
-            <a:pPr marL="0" indent="0">
+            <a:pPr indent="0" marL="0">
               <a:buNone/>
             </a:pPr>
             <a:r>
@@ -10046,7 +9960,7 @@
           <a:bodyPr wrap="square" lIns="0" tIns="0" rIns="0" bIns="0" rtlCol="0" anchor="ctr"/>
           <a:lstStyle/>
           <a:p>
-            <a:pPr marL="0" indent="0" algn="r">
+            <a:pPr algn="r" indent="0" marL="0">
               <a:buNone/>
             </a:pPr>
             <a:r>
@@ -10080,7 +9994,6 @@
         <a:solidFill>
           <a:srgbClr val="FFFFFF"/>
         </a:solidFill>
-        <a:effectLst/>
       </p:bgPr>
     </p:bg>
     <p:spTree>
@@ -10118,7 +10031,7 @@
           <a:bodyPr wrap="square" lIns="0" tIns="0" rIns="0" bIns="0" rtlCol="0" anchor="ctr"/>
           <a:lstStyle/>
           <a:p>
-            <a:pPr marL="0" indent="0">
+            <a:pPr indent="0" marL="0">
               <a:buNone/>
             </a:pPr>
             <a:r>
@@ -10144,12 +10057,12 @@
         </p:nvSpPr>
         <p:spPr>
           <a:xfrm>
-            <a:off x="658368" y="1371600"/>
-            <a:ext cx="2459736" cy="2670048"/>
+            <a:off x="658368" y="1316736"/>
+            <a:ext cx="2459736" cy="2395728"/>
           </a:xfrm>
           <a:prstGeom prst="roundRect">
             <a:avLst>
-              <a:gd name="adj" fmla="val 2974"/>
+              <a:gd name="adj" fmla="val 3053"/>
             </a:avLst>
           </a:prstGeom>
           <a:solidFill>
@@ -10162,13 +10075,6 @@
             <a:prstDash val="solid"/>
           </a:ln>
         </p:spPr>
-        <p:txBody>
-          <a:bodyPr/>
-          <a:lstStyle/>
-          <a:p>
-            <a:endParaRPr lang="ja-JP" altLang="en-US"/>
-          </a:p>
-        </p:txBody>
       </p:sp>
       <p:sp>
         <p:nvSpPr>
@@ -10178,7 +10084,7 @@
         </p:nvSpPr>
         <p:spPr>
           <a:xfrm>
-            <a:off x="969264" y="1700784"/>
+            <a:off x="969264" y="1572768"/>
             <a:ext cx="402336" cy="402336"/>
           </a:xfrm>
           <a:prstGeom prst="ellipse">
@@ -10194,13 +10100,6 @@
             <a:prstDash val="solid"/>
           </a:ln>
         </p:spPr>
-        <p:txBody>
-          <a:bodyPr/>
-          <a:lstStyle/>
-          <a:p>
-            <a:endParaRPr lang="ja-JP" altLang="en-US"/>
-          </a:p>
-        </p:txBody>
       </p:sp>
       <p:sp>
         <p:nvSpPr>
@@ -10210,7 +10109,7 @@
         </p:nvSpPr>
         <p:spPr>
           <a:xfrm>
-            <a:off x="969264" y="1700784"/>
+            <a:off x="969264" y="1572768"/>
             <a:ext cx="402336" cy="402336"/>
           </a:xfrm>
           <a:prstGeom prst="rect">
@@ -10223,7 +10122,7 @@
           <a:bodyPr wrap="square" lIns="0" tIns="0" rIns="0" bIns="0" rtlCol="0" anchor="ctr"/>
           <a:lstStyle/>
           <a:p>
-            <a:pPr marL="0" indent="0" algn="ctr">
+            <a:pPr algn="ctr" indent="0" marL="0">
               <a:buNone/>
             </a:pPr>
             <a:r>
@@ -10249,7 +10148,7 @@
         </p:nvSpPr>
         <p:spPr>
           <a:xfrm>
-            <a:off x="969264" y="2286000"/>
+            <a:off x="969264" y="2084832"/>
             <a:ext cx="1837944" cy="420624"/>
           </a:xfrm>
           <a:prstGeom prst="rect">
@@ -10262,7 +10161,7 @@
           <a:bodyPr wrap="square" lIns="0" tIns="0" rIns="0" bIns="0" rtlCol="0" anchor="ctr"/>
           <a:lstStyle/>
           <a:p>
-            <a:pPr marL="0" indent="0">
+            <a:pPr indent="0" marL="0">
               <a:buNone/>
             </a:pPr>
             <a:r>
@@ -10288,20 +10187,20 @@
         </p:nvSpPr>
         <p:spPr>
           <a:xfrm>
-            <a:off x="969264" y="2779776"/>
-            <a:ext cx="1837944" cy="1097280"/>
-          </a:xfrm>
-          <a:prstGeom prst="rect">
-            <a:avLst/>
-          </a:prstGeom>
-          <a:noFill/>
-          <a:ln/>
-        </p:spPr>
-        <p:txBody>
-          <a:bodyPr wrap="square" lIns="0" tIns="0" rIns="0" bIns="0" rtlCol="0" anchor="ctr"/>
-          <a:lstStyle/>
-          <a:p>
-            <a:pPr marL="0" indent="0">
+            <a:off x="969264" y="2523744"/>
+            <a:ext cx="1837944" cy="1051560"/>
+          </a:xfrm>
+          <a:prstGeom prst="rect">
+            <a:avLst/>
+          </a:prstGeom>
+          <a:noFill/>
+          <a:ln/>
+        </p:spPr>
+        <p:txBody>
+          <a:bodyPr wrap="square" lIns="0" tIns="0" rIns="0" bIns="0" rtlCol="0" anchor="ctr"/>
+          <a:lstStyle/>
+          <a:p>
+            <a:pPr indent="0" marL="0">
               <a:lnSpc>
                 <a:spcPct val="135000"/>
               </a:lnSpc>
@@ -10330,7 +10229,7 @@
         </p:nvSpPr>
         <p:spPr>
           <a:xfrm>
-            <a:off x="3182112" y="2569464"/>
+            <a:off x="3182112" y="2377440"/>
             <a:ext cx="219456" cy="274320"/>
           </a:xfrm>
           <a:prstGeom prst="rightArrow">
@@ -10346,13 +10245,6 @@
             <a:prstDash val="solid"/>
           </a:ln>
         </p:spPr>
-        <p:txBody>
-          <a:bodyPr/>
-          <a:lstStyle/>
-          <a:p>
-            <a:endParaRPr lang="ja-JP" altLang="en-US"/>
-          </a:p>
-        </p:txBody>
       </p:sp>
       <p:sp>
         <p:nvSpPr>
@@ -10362,12 +10254,12 @@
         </p:nvSpPr>
         <p:spPr>
           <a:xfrm>
-            <a:off x="3465576" y="1371600"/>
-            <a:ext cx="2459736" cy="2670048"/>
+            <a:off x="3465576" y="1316736"/>
+            <a:ext cx="2459736" cy="2395728"/>
           </a:xfrm>
           <a:prstGeom prst="roundRect">
             <a:avLst>
-              <a:gd name="adj" fmla="val 2974"/>
+              <a:gd name="adj" fmla="val 3053"/>
             </a:avLst>
           </a:prstGeom>
           <a:solidFill>
@@ -10380,13 +10272,6 @@
             <a:prstDash val="solid"/>
           </a:ln>
         </p:spPr>
-        <p:txBody>
-          <a:bodyPr/>
-          <a:lstStyle/>
-          <a:p>
-            <a:endParaRPr lang="ja-JP" altLang="en-US"/>
-          </a:p>
-        </p:txBody>
       </p:sp>
       <p:sp>
         <p:nvSpPr>
@@ -10396,7 +10281,7 @@
         </p:nvSpPr>
         <p:spPr>
           <a:xfrm>
-            <a:off x="3776472" y="1700784"/>
+            <a:off x="3776472" y="1572768"/>
             <a:ext cx="402336" cy="402336"/>
           </a:xfrm>
           <a:prstGeom prst="ellipse">
@@ -10412,13 +10297,6 @@
             <a:prstDash val="solid"/>
           </a:ln>
         </p:spPr>
-        <p:txBody>
-          <a:bodyPr/>
-          <a:lstStyle/>
-          <a:p>
-            <a:endParaRPr lang="ja-JP" altLang="en-US"/>
-          </a:p>
-        </p:txBody>
       </p:sp>
       <p:sp>
         <p:nvSpPr>
@@ -10428,7 +10306,7 @@
         </p:nvSpPr>
         <p:spPr>
           <a:xfrm>
-            <a:off x="3776472" y="1700784"/>
+            <a:off x="3776472" y="1572768"/>
             <a:ext cx="402336" cy="402336"/>
           </a:xfrm>
           <a:prstGeom prst="rect">
@@ -10441,7 +10319,7 @@
           <a:bodyPr wrap="square" lIns="0" tIns="0" rIns="0" bIns="0" rtlCol="0" anchor="ctr"/>
           <a:lstStyle/>
           <a:p>
-            <a:pPr marL="0" indent="0" algn="ctr">
+            <a:pPr algn="ctr" indent="0" marL="0">
               <a:buNone/>
             </a:pPr>
             <a:r>
@@ -10467,7 +10345,7 @@
         </p:nvSpPr>
         <p:spPr>
           <a:xfrm>
-            <a:off x="3776472" y="2286000"/>
+            <a:off x="3776472" y="2084832"/>
             <a:ext cx="1837944" cy="420624"/>
           </a:xfrm>
           <a:prstGeom prst="rect">
@@ -10480,7 +10358,7 @@
           <a:bodyPr wrap="square" lIns="0" tIns="0" rIns="0" bIns="0" rtlCol="0" anchor="ctr"/>
           <a:lstStyle/>
           <a:p>
-            <a:pPr marL="0" indent="0">
+            <a:pPr indent="0" marL="0">
               <a:buNone/>
             </a:pPr>
             <a:r>
@@ -10506,20 +10384,20 @@
         </p:nvSpPr>
         <p:spPr>
           <a:xfrm>
-            <a:off x="3776472" y="2779776"/>
-            <a:ext cx="1837944" cy="1097280"/>
-          </a:xfrm>
-          <a:prstGeom prst="rect">
-            <a:avLst/>
-          </a:prstGeom>
-          <a:noFill/>
-          <a:ln/>
-        </p:spPr>
-        <p:txBody>
-          <a:bodyPr wrap="square" lIns="0" tIns="0" rIns="0" bIns="0" rtlCol="0" anchor="ctr"/>
-          <a:lstStyle/>
-          <a:p>
-            <a:pPr marL="0" indent="0">
+            <a:off x="3776472" y="2523744"/>
+            <a:ext cx="1837944" cy="1051560"/>
+          </a:xfrm>
+          <a:prstGeom prst="rect">
+            <a:avLst/>
+          </a:prstGeom>
+          <a:noFill/>
+          <a:ln/>
+        </p:spPr>
+        <p:txBody>
+          <a:bodyPr wrap="square" lIns="0" tIns="0" rIns="0" bIns="0" rtlCol="0" anchor="ctr"/>
+          <a:lstStyle/>
+          <a:p>
+            <a:pPr indent="0" marL="0">
               <a:lnSpc>
                 <a:spcPct val="135000"/>
               </a:lnSpc>
@@ -10548,7 +10426,7 @@
         </p:nvSpPr>
         <p:spPr>
           <a:xfrm>
-            <a:off x="5989320" y="2569464"/>
+            <a:off x="5989320" y="2377440"/>
             <a:ext cx="219456" cy="274320"/>
           </a:xfrm>
           <a:prstGeom prst="rightArrow">
@@ -10564,13 +10442,6 @@
             <a:prstDash val="solid"/>
           </a:ln>
         </p:spPr>
-        <p:txBody>
-          <a:bodyPr/>
-          <a:lstStyle/>
-          <a:p>
-            <a:endParaRPr lang="ja-JP" altLang="en-US"/>
-          </a:p>
-        </p:txBody>
       </p:sp>
       <p:sp>
         <p:nvSpPr>
@@ -10580,12 +10451,12 @@
         </p:nvSpPr>
         <p:spPr>
           <a:xfrm>
-            <a:off x="6272784" y="1371600"/>
-            <a:ext cx="2459736" cy="2670048"/>
+            <a:off x="6272784" y="1316736"/>
+            <a:ext cx="2459736" cy="2395728"/>
           </a:xfrm>
           <a:prstGeom prst="roundRect">
             <a:avLst>
-              <a:gd name="adj" fmla="val 2974"/>
+              <a:gd name="adj" fmla="val 3053"/>
             </a:avLst>
           </a:prstGeom>
           <a:solidFill>
@@ -10598,13 +10469,6 @@
             <a:prstDash val="solid"/>
           </a:ln>
         </p:spPr>
-        <p:txBody>
-          <a:bodyPr/>
-          <a:lstStyle/>
-          <a:p>
-            <a:endParaRPr lang="ja-JP" altLang="en-US"/>
-          </a:p>
-        </p:txBody>
       </p:sp>
       <p:sp>
         <p:nvSpPr>
@@ -10614,7 +10478,7 @@
         </p:nvSpPr>
         <p:spPr>
           <a:xfrm>
-            <a:off x="6583680" y="1700784"/>
+            <a:off x="6583680" y="1572768"/>
             <a:ext cx="402336" cy="402336"/>
           </a:xfrm>
           <a:prstGeom prst="ellipse">
@@ -10630,13 +10494,6 @@
             <a:prstDash val="solid"/>
           </a:ln>
         </p:spPr>
-        <p:txBody>
-          <a:bodyPr/>
-          <a:lstStyle/>
-          <a:p>
-            <a:endParaRPr lang="ja-JP" altLang="en-US"/>
-          </a:p>
-        </p:txBody>
       </p:sp>
       <p:sp>
         <p:nvSpPr>
@@ -10646,7 +10503,7 @@
         </p:nvSpPr>
         <p:spPr>
           <a:xfrm>
-            <a:off x="6583680" y="1700784"/>
+            <a:off x="6583680" y="1572768"/>
             <a:ext cx="402336" cy="402336"/>
           </a:xfrm>
           <a:prstGeom prst="rect">
@@ -10659,7 +10516,7 @@
           <a:bodyPr wrap="square" lIns="0" tIns="0" rIns="0" bIns="0" rtlCol="0" anchor="ctr"/>
           <a:lstStyle/>
           <a:p>
-            <a:pPr marL="0" indent="0" algn="ctr">
+            <a:pPr algn="ctr" indent="0" marL="0">
               <a:buNone/>
             </a:pPr>
             <a:r>
@@ -10685,7 +10542,7 @@
         </p:nvSpPr>
         <p:spPr>
           <a:xfrm>
-            <a:off x="6583680" y="2286000"/>
+            <a:off x="6583680" y="2084832"/>
             <a:ext cx="1837944" cy="420624"/>
           </a:xfrm>
           <a:prstGeom prst="rect">
@@ -10698,7 +10555,7 @@
           <a:bodyPr wrap="square" lIns="0" tIns="0" rIns="0" bIns="0" rtlCol="0" anchor="ctr"/>
           <a:lstStyle/>
           <a:p>
-            <a:pPr marL="0" indent="0">
+            <a:pPr indent="0" marL="0">
               <a:buNone/>
             </a:pPr>
             <a:r>
@@ -10724,20 +10581,20 @@
         </p:nvSpPr>
         <p:spPr>
           <a:xfrm>
-            <a:off x="6583680" y="2779776"/>
-            <a:ext cx="1837944" cy="1097280"/>
-          </a:xfrm>
-          <a:prstGeom prst="rect">
-            <a:avLst/>
-          </a:prstGeom>
-          <a:noFill/>
-          <a:ln/>
-        </p:spPr>
-        <p:txBody>
-          <a:bodyPr wrap="square" lIns="0" tIns="0" rIns="0" bIns="0" rtlCol="0" anchor="ctr"/>
-          <a:lstStyle/>
-          <a:p>
-            <a:pPr marL="0" indent="0">
+            <a:off x="6583680" y="2523744"/>
+            <a:ext cx="1837944" cy="1051560"/>
+          </a:xfrm>
+          <a:prstGeom prst="rect">
+            <a:avLst/>
+          </a:prstGeom>
+          <a:noFill/>
+          <a:ln/>
+        </p:spPr>
+        <p:txBody>
+          <a:bodyPr wrap="square" lIns="0" tIns="0" rIns="0" bIns="0" rtlCol="0" anchor="ctr"/>
+          <a:lstStyle/>
+          <a:p>
+            <a:pPr indent="0" marL="0">
               <a:lnSpc>
                 <a:spcPct val="135000"/>
               </a:lnSpc>
@@ -10766,7 +10623,7 @@
         </p:nvSpPr>
         <p:spPr>
           <a:xfrm>
-            <a:off x="8796528" y="2569464"/>
+            <a:off x="8796528" y="2377440"/>
             <a:ext cx="219456" cy="274320"/>
           </a:xfrm>
           <a:prstGeom prst="rightArrow">
@@ -10782,13 +10639,6 @@
             <a:prstDash val="solid"/>
           </a:ln>
         </p:spPr>
-        <p:txBody>
-          <a:bodyPr/>
-          <a:lstStyle/>
-          <a:p>
-            <a:endParaRPr lang="ja-JP" altLang="en-US"/>
-          </a:p>
-        </p:txBody>
       </p:sp>
       <p:sp>
         <p:nvSpPr>
@@ -10798,12 +10648,12 @@
         </p:nvSpPr>
         <p:spPr>
           <a:xfrm>
-            <a:off x="9079992" y="1371600"/>
-            <a:ext cx="2459736" cy="2670048"/>
+            <a:off x="9079992" y="1316736"/>
+            <a:ext cx="2459736" cy="2395728"/>
           </a:xfrm>
           <a:prstGeom prst="roundRect">
             <a:avLst>
-              <a:gd name="adj" fmla="val 2974"/>
+              <a:gd name="adj" fmla="val 3053"/>
             </a:avLst>
           </a:prstGeom>
           <a:solidFill>
@@ -10816,13 +10666,6 @@
             <a:prstDash val="solid"/>
           </a:ln>
         </p:spPr>
-        <p:txBody>
-          <a:bodyPr/>
-          <a:lstStyle/>
-          <a:p>
-            <a:endParaRPr lang="ja-JP" altLang="en-US"/>
-          </a:p>
-        </p:txBody>
       </p:sp>
       <p:sp>
         <p:nvSpPr>
@@ -10832,7 +10675,7 @@
         </p:nvSpPr>
         <p:spPr>
           <a:xfrm>
-            <a:off x="9390888" y="1700784"/>
+            <a:off x="9390888" y="1572768"/>
             <a:ext cx="402336" cy="402336"/>
           </a:xfrm>
           <a:prstGeom prst="ellipse">
@@ -10848,13 +10691,6 @@
             <a:prstDash val="solid"/>
           </a:ln>
         </p:spPr>
-        <p:txBody>
-          <a:bodyPr/>
-          <a:lstStyle/>
-          <a:p>
-            <a:endParaRPr lang="ja-JP" altLang="en-US"/>
-          </a:p>
-        </p:txBody>
       </p:sp>
       <p:sp>
         <p:nvSpPr>
@@ -10864,7 +10700,7 @@
         </p:nvSpPr>
         <p:spPr>
           <a:xfrm>
-            <a:off x="9390888" y="1700784"/>
+            <a:off x="9390888" y="1572768"/>
             <a:ext cx="402336" cy="402336"/>
           </a:xfrm>
           <a:prstGeom prst="rect">
@@ -10877,7 +10713,7 @@
           <a:bodyPr wrap="square" lIns="0" tIns="0" rIns="0" bIns="0" rtlCol="0" anchor="ctr"/>
           <a:lstStyle/>
           <a:p>
-            <a:pPr marL="0" indent="0" algn="ctr">
+            <a:pPr algn="ctr" indent="0" marL="0">
               <a:buNone/>
             </a:pPr>
             <a:r>
@@ -10903,7 +10739,7 @@
         </p:nvSpPr>
         <p:spPr>
           <a:xfrm>
-            <a:off x="9390888" y="2286000"/>
+            <a:off x="9390888" y="2084832"/>
             <a:ext cx="1837944" cy="420624"/>
           </a:xfrm>
           <a:prstGeom prst="rect">
@@ -10916,7 +10752,7 @@
           <a:bodyPr wrap="square" lIns="0" tIns="0" rIns="0" bIns="0" rtlCol="0" anchor="ctr"/>
           <a:lstStyle/>
           <a:p>
-            <a:pPr marL="0" indent="0">
+            <a:pPr indent="0" marL="0">
               <a:buNone/>
             </a:pPr>
             <a:r>
@@ -10942,20 +10778,20 @@
         </p:nvSpPr>
         <p:spPr>
           <a:xfrm>
-            <a:off x="9390888" y="2779776"/>
-            <a:ext cx="1837944" cy="1097280"/>
-          </a:xfrm>
-          <a:prstGeom prst="rect">
-            <a:avLst/>
-          </a:prstGeom>
-          <a:noFill/>
-          <a:ln/>
-        </p:spPr>
-        <p:txBody>
-          <a:bodyPr wrap="square" lIns="0" tIns="0" rIns="0" bIns="0" rtlCol="0" anchor="ctr"/>
-          <a:lstStyle/>
-          <a:p>
-            <a:pPr marL="0" indent="0">
+            <a:off x="9390888" y="2523744"/>
+            <a:ext cx="1837944" cy="1051560"/>
+          </a:xfrm>
+          <a:prstGeom prst="rect">
+            <a:avLst/>
+          </a:prstGeom>
+          <a:noFill/>
+          <a:ln/>
+        </p:spPr>
+        <p:txBody>
+          <a:bodyPr wrap="square" lIns="0" tIns="0" rIns="0" bIns="0" rtlCol="0" anchor="ctr"/>
+          <a:lstStyle/>
+          <a:p>
+            <a:pPr indent="0" marL="0">
               <a:lnSpc>
                 <a:spcPct val="135000"/>
               </a:lnSpc>
@@ -10984,12 +10820,12 @@
         </p:nvSpPr>
         <p:spPr>
           <a:xfrm>
-            <a:off x="658368" y="4407408"/>
-            <a:ext cx="10872216" cy="1225296"/>
+            <a:off x="658368" y="3986784"/>
+            <a:ext cx="10872216" cy="1828800"/>
           </a:xfrm>
           <a:prstGeom prst="roundRect">
             <a:avLst>
-              <a:gd name="adj" fmla="val 4478"/>
+              <a:gd name="adj" fmla="val 3000"/>
             </a:avLst>
           </a:prstGeom>
           <a:solidFill>
@@ -11002,13 +10838,6 @@
             <a:prstDash val="solid"/>
           </a:ln>
         </p:spPr>
-        <p:txBody>
-          <a:bodyPr/>
-          <a:lstStyle/>
-          <a:p>
-            <a:endParaRPr lang="ja-JP" altLang="en-US"/>
-          </a:p>
-        </p:txBody>
       </p:sp>
       <p:sp>
         <p:nvSpPr>
@@ -11018,24 +10847,24 @@
         </p:nvSpPr>
         <p:spPr>
           <a:xfrm>
-            <a:off x="1042416" y="4590288"/>
-            <a:ext cx="2926080" cy="274320"/>
-          </a:xfrm>
-          <a:prstGeom prst="rect">
-            <a:avLst/>
-          </a:prstGeom>
-          <a:noFill/>
-          <a:ln/>
-        </p:spPr>
-        <p:txBody>
-          <a:bodyPr wrap="square" lIns="0" tIns="0" rIns="0" bIns="0" rtlCol="0" anchor="ctr"/>
-          <a:lstStyle/>
-          <a:p>
-            <a:pPr marL="0" indent="0">
-              <a:buNone/>
-            </a:pPr>
-            <a:r>
-              <a:rPr lang="en-US" sz="1200" b="1" dirty="0">
+            <a:off x="1042416" y="4133088"/>
+            <a:ext cx="8229600" cy="256032"/>
+          </a:xfrm>
+          <a:prstGeom prst="rect">
+            <a:avLst/>
+          </a:prstGeom>
+          <a:noFill/>
+          <a:ln/>
+        </p:spPr>
+        <p:txBody>
+          <a:bodyPr wrap="square" lIns="0" tIns="0" rIns="0" bIns="0" rtlCol="0" anchor="ctr"/>
+          <a:lstStyle/>
+          <a:p>
+            <a:pPr indent="0" marL="0">
+              <a:buNone/>
+            </a:pPr>
+            <a:r>
+              <a:rPr lang="en-US" sz="1300" b="1" dirty="0">
                 <a:solidFill>
                   <a:srgbClr val="CADCFC"/>
                 </a:solidFill>
@@ -11043,9 +10872,9 @@
                 <a:ea typeface="游ゴシック" pitchFamily="34" charset="-122"/>
                 <a:cs typeface="游ゴシック" pitchFamily="34" charset="-120"/>
               </a:rPr>
-              <a:t>この形にする理由</a:t>
-            </a:r>
-            <a:endParaRPr lang="en-US" sz="1200" dirty="0"/>
+              <a:t>構造化して比べると、なぜ分野をまたぐ「考え方」が見つかるのか</a:t>
+            </a:r>
+            <a:endParaRPr lang="en-US" sz="1300" dirty="0"/>
           </a:p>
         </p:txBody>
       </p:sp>
@@ -11057,27 +10886,130 @@
         </p:nvSpPr>
         <p:spPr>
           <a:xfrm>
-            <a:off x="1042416" y="4882896"/>
-            <a:ext cx="10058400" cy="658368"/>
-          </a:xfrm>
-          <a:prstGeom prst="rect">
-            <a:avLst/>
-          </a:prstGeom>
-          <a:noFill/>
-          <a:ln/>
-        </p:spPr>
-        <p:txBody>
-          <a:bodyPr wrap="square" lIns="0" tIns="0" rIns="0" bIns="0" rtlCol="0" anchor="ctr"/>
-          <a:lstStyle/>
-          <a:p>
-            <a:pPr marL="0" indent="0">
+            <a:off x="1042416" y="4462272"/>
+            <a:ext cx="3063240" cy="237744"/>
+          </a:xfrm>
+          <a:prstGeom prst="rect">
+            <a:avLst/>
+          </a:prstGeom>
+          <a:noFill/>
+          <a:ln/>
+        </p:spPr>
+        <p:txBody>
+          <a:bodyPr wrap="square" lIns="0" tIns="0" rIns="0" bIns="0" rtlCol="0" anchor="ctr"/>
+          <a:lstStyle/>
+          <a:p>
+            <a:pPr indent="0" marL="0">
+              <a:buNone/>
+            </a:pPr>
+            <a:r>
+              <a:rPr lang="en-US" sz="1250" b="1" dirty="0">
+                <a:solidFill>
+                  <a:srgbClr val="FFFFFF"/>
+                </a:solidFill>
+                <a:latin typeface="游ゴシック" pitchFamily="34" charset="0"/>
+                <a:ea typeface="游ゴシック" pitchFamily="34" charset="-122"/>
+                <a:cs typeface="游ゴシック" pitchFamily="34" charset="-120"/>
+              </a:rPr>
+              <a:t>① 分野が違っても、関係は残る</a:t>
+            </a:r>
+            <a:endParaRPr lang="en-US" sz="1250" dirty="0"/>
+          </a:p>
+        </p:txBody>
+      </p:sp>
+      <p:sp>
+        <p:nvSpPr>
+          <p:cNvPr id="29" name="Text 27"/>
+          <p:cNvSpPr txBox="1"/>
+          <p:nvPr/>
+        </p:nvSpPr>
+        <p:spPr>
+          <a:xfrm>
+            <a:off x="1042416" y="4736592"/>
+            <a:ext cx="3063240" cy="603504"/>
+          </a:xfrm>
+          <a:prstGeom prst="rect">
+            <a:avLst/>
+          </a:prstGeom>
+          <a:noFill/>
+          <a:ln/>
+        </p:spPr>
+        <p:txBody>
+          <a:bodyPr wrap="square" lIns="0" tIns="0" rIns="0" bIns="0" rtlCol="0" anchor="ctr"/>
+          <a:lstStyle/>
+          <a:p>
+            <a:pPr indent="0" marL="0">
               <a:lnSpc>
                 <a:spcPct val="128000"/>
               </a:lnSpc>
               <a:buNone/>
             </a:pPr>
             <a:r>
-              <a:rPr lang="en-US" sz="1400" dirty="0">
+              <a:rPr lang="en-US" sz="1100" dirty="0">
+                <a:solidFill>
+                  <a:srgbClr val="CADCFC"/>
+                </a:solidFill>
+                <a:latin typeface="游ゴシック" pitchFamily="34" charset="0"/>
+                <a:ea typeface="游ゴシック" pitchFamily="34" charset="-122"/>
+                <a:cs typeface="游ゴシック" pitchFamily="34" charset="-120"/>
+              </a:rPr>
+              <a:t>「人員を増やすと説明の時間が増える」と「製品種類を増やすと段取り時間が増える」は、言葉は違うが同じ関係</a:t>
+            </a:r>
+            <a:endParaRPr lang="en-US" sz="1100" dirty="0"/>
+          </a:p>
+        </p:txBody>
+      </p:sp>
+      <p:sp>
+        <p:nvSpPr>
+          <p:cNvPr id="30" name="Shape 28"/>
+          <p:cNvSpPr/>
+          <p:nvPr/>
+        </p:nvSpPr>
+        <p:spPr>
+          <a:xfrm>
+            <a:off x="4215384" y="4736592"/>
+            <a:ext cx="237744" cy="256032"/>
+          </a:xfrm>
+          <a:prstGeom prst="rightArrow">
+            <a:avLst/>
+          </a:prstGeom>
+          <a:solidFill>
+            <a:srgbClr val="E97132"/>
+          </a:solidFill>
+          <a:ln w="12700">
+            <a:solidFill>
+              <a:srgbClr val="333333"/>
+            </a:solidFill>
+            <a:prstDash val="solid"/>
+          </a:ln>
+        </p:spPr>
+      </p:sp>
+      <p:sp>
+        <p:nvSpPr>
+          <p:cNvPr id="31" name="Text 29"/>
+          <p:cNvSpPr txBox="1"/>
+          <p:nvPr/>
+        </p:nvSpPr>
+        <p:spPr>
+          <a:xfrm>
+            <a:off x="4562856" y="4462272"/>
+            <a:ext cx="3063240" cy="237744"/>
+          </a:xfrm>
+          <a:prstGeom prst="rect">
+            <a:avLst/>
+          </a:prstGeom>
+          <a:noFill/>
+          <a:ln/>
+        </p:spPr>
+        <p:txBody>
+          <a:bodyPr wrap="square" lIns="0" tIns="0" rIns="0" bIns="0" rtlCol="0" anchor="ctr"/>
+          <a:lstStyle/>
+          <a:p>
+            <a:pPr indent="0" marL="0">
+              <a:buNone/>
+            </a:pPr>
+            <a:r>
+              <a:rPr lang="en-US" sz="1250" b="1" dirty="0">
                 <a:solidFill>
                   <a:srgbClr val="FFFFFF"/>
                 </a:solidFill>
@@ -11085,19 +11017,105 @@
                 <a:ea typeface="游ゴシック" pitchFamily="34" charset="-122"/>
                 <a:cs typeface="游ゴシック" pitchFamily="34" charset="-120"/>
               </a:rPr>
-              <a:t>事例どうしを総当たりで比較させるのではなく、1件ずつ構造にしておき、比較はプログラムで行う。</a:t>
-            </a:r>
-            <a:endParaRPr lang="en-US" sz="1400" dirty="0"/>
-          </a:p>
-          <a:p>
-            <a:pPr marL="0" indent="0">
+              <a:t>② その関係のまとまりが「考え方」</a:t>
+            </a:r>
+            <a:endParaRPr lang="en-US" sz="1250" dirty="0"/>
+          </a:p>
+        </p:txBody>
+      </p:sp>
+      <p:sp>
+        <p:nvSpPr>
+          <p:cNvPr id="32" name="Text 30"/>
+          <p:cNvSpPr txBox="1"/>
+          <p:nvPr/>
+        </p:nvSpPr>
+        <p:spPr>
+          <a:xfrm>
+            <a:off x="4562856" y="4736592"/>
+            <a:ext cx="3063240" cy="603504"/>
+          </a:xfrm>
+          <a:prstGeom prst="rect">
+            <a:avLst/>
+          </a:prstGeom>
+          <a:noFill/>
+          <a:ln/>
+        </p:spPr>
+        <p:txBody>
+          <a:bodyPr wrap="square" lIns="0" tIns="0" rIns="0" bIns="0" rtlCol="0" anchor="ctr"/>
+          <a:lstStyle/>
+          <a:p>
+            <a:pPr indent="0" marL="0">
               <a:lnSpc>
                 <a:spcPct val="128000"/>
               </a:lnSpc>
               <a:buNone/>
             </a:pPr>
             <a:r>
-              <a:rPr lang="en-US" sz="1400" dirty="0">
+              <a:rPr lang="en-US" sz="1100" dirty="0">
+                <a:solidFill>
+                  <a:srgbClr val="CADCFC"/>
+                </a:solidFill>
+                <a:latin typeface="游ゴシック" pitchFamily="34" charset="0"/>
+                <a:ea typeface="游ゴシック" pitchFamily="34" charset="-122"/>
+                <a:cs typeface="游ゴシック" pitchFamily="34" charset="-120"/>
+              </a:rPr>
+              <a:t>何をすると何が起きるか、という関係の組み合わせが熟練者の考え方。類推でも、対象の属性ではなく関係の対応づけが中核とされる</a:t>
+            </a:r>
+            <a:endParaRPr lang="en-US" sz="1100" dirty="0"/>
+          </a:p>
+        </p:txBody>
+      </p:sp>
+      <p:sp>
+        <p:nvSpPr>
+          <p:cNvPr id="33" name="Shape 31"/>
+          <p:cNvSpPr/>
+          <p:nvPr/>
+        </p:nvSpPr>
+        <p:spPr>
+          <a:xfrm>
+            <a:off x="7735824" y="4736592"/>
+            <a:ext cx="237744" cy="256032"/>
+          </a:xfrm>
+          <a:prstGeom prst="rightArrow">
+            <a:avLst/>
+          </a:prstGeom>
+          <a:solidFill>
+            <a:srgbClr val="E97132"/>
+          </a:solidFill>
+          <a:ln w="12700">
+            <a:solidFill>
+              <a:srgbClr val="333333"/>
+            </a:solidFill>
+            <a:prstDash val="solid"/>
+          </a:ln>
+        </p:spPr>
+      </p:sp>
+      <p:sp>
+        <p:nvSpPr>
+          <p:cNvPr id="34" name="Text 32"/>
+          <p:cNvSpPr txBox="1"/>
+          <p:nvPr/>
+        </p:nvSpPr>
+        <p:spPr>
+          <a:xfrm>
+            <a:off x="8083296" y="4462272"/>
+            <a:ext cx="3063240" cy="237744"/>
+          </a:xfrm>
+          <a:prstGeom prst="rect">
+            <a:avLst/>
+          </a:prstGeom>
+          <a:noFill/>
+          <a:ln/>
+        </p:spPr>
+        <p:txBody>
+          <a:bodyPr wrap="square" lIns="0" tIns="0" rIns="0" bIns="0" rtlCol="0" anchor="ctr"/>
+          <a:lstStyle/>
+          <a:p>
+            <a:pPr indent="0" marL="0">
+              <a:buNone/>
+            </a:pPr>
+            <a:r>
+              <a:rPr lang="en-US" sz="1250" b="1" dirty="0">
                 <a:solidFill>
                   <a:srgbClr val="FFFFFF"/>
                 </a:solidFill>
@@ -11105,21 +11123,102 @@
                 <a:ea typeface="游ゴシック" pitchFamily="34" charset="-122"/>
                 <a:cs typeface="游ゴシック" pitchFamily="34" charset="-120"/>
               </a:rPr>
-              <a:t>見つかった構造は、どの事例のどの記述から来たのかを必ず元の原文までたどれるようにする。</a:t>
-            </a:r>
-            <a:endParaRPr lang="en-US" sz="1400" dirty="0"/>
-          </a:p>
-        </p:txBody>
-      </p:sp>
-      <p:sp>
-        <p:nvSpPr>
-          <p:cNvPr id="29" name="Text 27"/>
-          <p:cNvSpPr txBox="1"/>
-          <p:nvPr/>
-        </p:nvSpPr>
-        <p:spPr>
-          <a:xfrm>
-            <a:off x="658368" y="5797296"/>
+              <a:t>③ 繰り返す構造が候補になる</a:t>
+            </a:r>
+            <a:endParaRPr lang="en-US" sz="1250" dirty="0"/>
+          </a:p>
+        </p:txBody>
+      </p:sp>
+      <p:sp>
+        <p:nvSpPr>
+          <p:cNvPr id="35" name="Text 33"/>
+          <p:cNvSpPr txBox="1"/>
+          <p:nvPr/>
+        </p:nvSpPr>
+        <p:spPr>
+          <a:xfrm>
+            <a:off x="8083296" y="4736592"/>
+            <a:ext cx="3063240" cy="603504"/>
+          </a:xfrm>
+          <a:prstGeom prst="rect">
+            <a:avLst/>
+          </a:prstGeom>
+          <a:noFill/>
+          <a:ln/>
+        </p:spPr>
+        <p:txBody>
+          <a:bodyPr wrap="square" lIns="0" tIns="0" rIns="0" bIns="0" rtlCol="0" anchor="ctr"/>
+          <a:lstStyle/>
+          <a:p>
+            <a:pPr indent="0" marL="0">
+              <a:lnSpc>
+                <a:spcPct val="128000"/>
+              </a:lnSpc>
+              <a:buNone/>
+            </a:pPr>
+            <a:r>
+              <a:rPr lang="en-US" sz="1100" dirty="0">
+                <a:solidFill>
+                  <a:srgbClr val="CADCFC"/>
+                </a:solidFill>
+                <a:latin typeface="游ゴシック" pitchFamily="34" charset="0"/>
+                <a:ea typeface="游ゴシック" pitchFamily="34" charset="-122"/>
+                <a:cs typeface="游ゴシック" pitchFamily="34" charset="-120"/>
+              </a:rPr>
+              <a:t>複数の分野に共通して現れる関係の構造は、分野を超えて成り立つ考え方の候補になる</a:t>
+            </a:r>
+            <a:endParaRPr lang="en-US" sz="1100" dirty="0"/>
+          </a:p>
+        </p:txBody>
+      </p:sp>
+      <p:sp>
+        <p:nvSpPr>
+          <p:cNvPr id="36" name="Text 34"/>
+          <p:cNvSpPr txBox="1"/>
+          <p:nvPr/>
+        </p:nvSpPr>
+        <p:spPr>
+          <a:xfrm>
+            <a:off x="1042416" y="5449824"/>
+            <a:ext cx="10058400" cy="256032"/>
+          </a:xfrm>
+          <a:prstGeom prst="rect">
+            <a:avLst/>
+          </a:prstGeom>
+          <a:noFill/>
+          <a:ln/>
+        </p:spPr>
+        <p:txBody>
+          <a:bodyPr wrap="square" lIns="0" tIns="0" rIns="0" bIns="0" rtlCol="0" anchor="ctr"/>
+          <a:lstStyle/>
+          <a:p>
+            <a:pPr indent="0" marL="0">
+              <a:buNone/>
+            </a:pPr>
+            <a:r>
+              <a:rPr lang="en-US" sz="1200" dirty="0">
+                <a:solidFill>
+                  <a:srgbClr val="BDD0E0"/>
+                </a:solidFill>
+                <a:latin typeface="游ゴシック" pitchFamily="34" charset="0"/>
+                <a:ea typeface="游ゴシック" pitchFamily="34" charset="-122"/>
+                <a:cs typeface="游ゴシック" pitchFamily="34" charset="-120"/>
+              </a:rPr>
+              <a:t>加えて、一度構造にしておけば原文どうしの総当たり比較が不要になり、件数が増えても機械的に照合できる</a:t>
+            </a:r>
+            <a:endParaRPr lang="en-US" sz="1200" dirty="0"/>
+          </a:p>
+        </p:txBody>
+      </p:sp>
+      <p:sp>
+        <p:nvSpPr>
+          <p:cNvPr id="37" name="Text 35"/>
+          <p:cNvSpPr txBox="1"/>
+          <p:nvPr/>
+        </p:nvSpPr>
+        <p:spPr>
+          <a:xfrm>
+            <a:off x="658368" y="5907024"/>
             <a:ext cx="10881360" cy="274320"/>
           </a:xfrm>
           <a:prstGeom prst="rect">
@@ -11132,7 +11231,7 @@
           <a:bodyPr wrap="square" lIns="0" tIns="0" rIns="0" bIns="0" rtlCol="0" anchor="ctr"/>
           <a:lstStyle/>
           <a:p>
-            <a:pPr marL="0" indent="0">
+            <a:pPr indent="0" marL="0">
               <a:buNone/>
             </a:pPr>
             <a:r>
@@ -11152,7 +11251,46 @@
       </p:sp>
       <p:sp>
         <p:nvSpPr>
-          <p:cNvPr id="30" name="Text 28"/>
+          <p:cNvPr id="38" name="Text 36"/>
+          <p:cNvSpPr txBox="1"/>
+          <p:nvPr/>
+        </p:nvSpPr>
+        <p:spPr>
+          <a:xfrm>
+            <a:off x="658368" y="6327648"/>
+            <a:ext cx="8961120" cy="237744"/>
+          </a:xfrm>
+          <a:prstGeom prst="rect">
+            <a:avLst/>
+          </a:prstGeom>
+          <a:noFill/>
+          <a:ln/>
+        </p:spPr>
+        <p:txBody>
+          <a:bodyPr wrap="square" lIns="0" tIns="0" rIns="0" bIns="0" rtlCol="0" anchor="ctr"/>
+          <a:lstStyle/>
+          <a:p>
+            <a:pPr indent="0" marL="0">
+              <a:buNone/>
+            </a:pPr>
+            <a:r>
+              <a:rPr lang="en-US" sz="900" dirty="0">
+                <a:solidFill>
+                  <a:srgbClr val="6B7A87"/>
+                </a:solidFill>
+                <a:latin typeface="Calibri" pitchFamily="34" charset="0"/>
+                <a:ea typeface="Calibri" pitchFamily="34" charset="-122"/>
+                <a:cs typeface="Calibri" pitchFamily="34" charset="-120"/>
+              </a:rPr>
+              <a:t>参考：Gentner, D. (1983). Structure-Mapping: A Theoretical Framework for Analogy. Cognitive Science, 7(2), 155–170.</a:t>
+            </a:r>
+            <a:endParaRPr lang="en-US" sz="900" dirty="0"/>
+          </a:p>
+        </p:txBody>
+      </p:sp>
+      <p:sp>
+        <p:nvSpPr>
+          <p:cNvPr id="39" name="Text 37"/>
           <p:cNvSpPr txBox="1"/>
           <p:nvPr/>
         </p:nvSpPr>
@@ -11171,7 +11309,7 @@
           <a:bodyPr wrap="square" lIns="0" tIns="0" rIns="0" bIns="0" rtlCol="0" anchor="ctr"/>
           <a:lstStyle/>
           <a:p>
-            <a:pPr marL="0" indent="0">
+            <a:pPr indent="0" marL="0">
               <a:buNone/>
             </a:pPr>
             <a:r>
@@ -11191,7 +11329,7 @@
       </p:sp>
       <p:sp>
         <p:nvSpPr>
-          <p:cNvPr id="31" name="Text 29"/>
+          <p:cNvPr id="40" name="Text 38"/>
           <p:cNvSpPr txBox="1"/>
           <p:nvPr/>
         </p:nvSpPr>
@@ -11210,7 +11348,7 @@
           <a:bodyPr wrap="square" lIns="0" tIns="0" rIns="0" bIns="0" rtlCol="0" anchor="ctr"/>
           <a:lstStyle/>
           <a:p>
-            <a:pPr marL="0" indent="0" algn="r">
+            <a:pPr algn="r" indent="0" marL="0">
               <a:buNone/>
             </a:pPr>
             <a:r>
@@ -11244,7 +11382,6 @@
         <a:solidFill>
           <a:srgbClr val="FFFFFF"/>
         </a:solidFill>
-        <a:effectLst/>
       </p:bgPr>
     </p:bg>
     <p:spTree>
@@ -11282,7 +11419,7 @@
           <a:bodyPr wrap="square" lIns="0" tIns="0" rIns="0" bIns="0" rtlCol="0" anchor="ctr"/>
           <a:lstStyle/>
           <a:p>
-            <a:pPr marL="0" indent="0">
+            <a:pPr indent="0" marL="0">
               <a:buNone/>
             </a:pPr>
             <a:r>
@@ -11326,13 +11463,6 @@
             <a:prstDash val="solid"/>
           </a:ln>
         </p:spPr>
-        <p:txBody>
-          <a:bodyPr/>
-          <a:lstStyle/>
-          <a:p>
-            <a:endParaRPr lang="ja-JP" altLang="en-US"/>
-          </a:p>
-        </p:txBody>
       </p:sp>
       <p:sp>
         <p:nvSpPr>
@@ -11355,7 +11485,7 @@
           <a:bodyPr wrap="square" lIns="0" tIns="0" rIns="0" bIns="0" rtlCol="0" anchor="ctr"/>
           <a:lstStyle/>
           <a:p>
-            <a:pPr marL="0" indent="0">
+            <a:pPr indent="0" marL="0">
               <a:buNone/>
             </a:pPr>
             <a:r>
@@ -11493,13 +11623,6 @@
             <a:prstDash val="solid"/>
           </a:ln>
         </p:spPr>
-        <p:txBody>
-          <a:bodyPr/>
-          <a:lstStyle/>
-          <a:p>
-            <a:endParaRPr lang="ja-JP" altLang="en-US"/>
-          </a:p>
-        </p:txBody>
       </p:sp>
       <p:sp>
         <p:nvSpPr>
@@ -11522,7 +11645,7 @@
           <a:bodyPr wrap="square" lIns="0" tIns="0" rIns="0" bIns="0" rtlCol="0" anchor="ctr"/>
           <a:lstStyle/>
           <a:p>
-            <a:pPr marL="0" indent="0">
+            <a:pPr indent="0" marL="0">
               <a:buNone/>
             </a:pPr>
             <a:r>
@@ -11660,13 +11783,6 @@
             <a:prstDash val="solid"/>
           </a:ln>
         </p:spPr>
-        <p:txBody>
-          <a:bodyPr/>
-          <a:lstStyle/>
-          <a:p>
-            <a:endParaRPr lang="ja-JP" altLang="en-US"/>
-          </a:p>
-        </p:txBody>
       </p:sp>
       <p:sp>
         <p:nvSpPr>
@@ -11694,13 +11810,6 @@
             <a:prstDash val="solid"/>
           </a:ln>
         </p:spPr>
-        <p:txBody>
-          <a:bodyPr/>
-          <a:lstStyle/>
-          <a:p>
-            <a:endParaRPr lang="ja-JP" altLang="en-US"/>
-          </a:p>
-        </p:txBody>
       </p:sp>
       <p:sp>
         <p:nvSpPr>
@@ -11723,7 +11832,7 @@
           <a:bodyPr wrap="square" lIns="0" tIns="0" rIns="0" bIns="0" rtlCol="0" anchor="ctr"/>
           <a:lstStyle/>
           <a:p>
-            <a:pPr marL="0" indent="0" algn="ctr">
+            <a:pPr algn="ctr" indent="0" marL="0">
               <a:buNone/>
             </a:pPr>
             <a:r>
@@ -11762,7 +11871,7 @@
           <a:bodyPr wrap="square" lIns="0" tIns="0" rIns="0" bIns="0" rtlCol="0" anchor="ctr"/>
           <a:lstStyle/>
           <a:p>
-            <a:pPr marL="0" indent="0">
+            <a:pPr indent="0" marL="0">
               <a:buNone/>
             </a:pPr>
             <a:r>
@@ -11801,7 +11910,7 @@
           <a:bodyPr wrap="square" lIns="0" tIns="0" rIns="0" bIns="0" rtlCol="0" anchor="ctr"/>
           <a:lstStyle/>
           <a:p>
-            <a:pPr marL="0" indent="0">
+            <a:pPr indent="0" marL="0">
               <a:lnSpc>
                 <a:spcPct val="130000"/>
               </a:lnSpc>
@@ -11821,7 +11930,7 @@
             <a:endParaRPr lang="en-US" sz="1150" dirty="0"/>
           </a:p>
           <a:p>
-            <a:pPr marL="0" indent="0">
+            <a:pPr indent="0" marL="0">
               <a:lnSpc>
                 <a:spcPct val="130000"/>
               </a:lnSpc>
@@ -11863,7 +11972,7 @@
           <a:bodyPr wrap="square" lIns="0" tIns="0" rIns="0" bIns="0" rtlCol="0" anchor="ctr"/>
           <a:lstStyle/>
           <a:p>
-            <a:pPr marL="0" indent="0">
+            <a:pPr indent="0" marL="0">
               <a:lnSpc>
                 <a:spcPct val="140000"/>
               </a:lnSpc>
@@ -11883,7 +11992,7 @@
             <a:endParaRPr lang="en-US" sz="1250" dirty="0"/>
           </a:p>
           <a:p>
-            <a:pPr marL="0" indent="0">
+            <a:pPr indent="0" marL="0">
               <a:lnSpc>
                 <a:spcPct val="140000"/>
               </a:lnSpc>
@@ -11903,7 +12012,7 @@
             <a:endParaRPr lang="en-US" sz="1250" dirty="0"/>
           </a:p>
           <a:p>
-            <a:pPr marL="0" indent="0">
+            <a:pPr indent="0" marL="0">
               <a:lnSpc>
                 <a:spcPct val="140000"/>
               </a:lnSpc>
@@ -11945,7 +12054,7 @@
           <a:bodyPr wrap="square" lIns="0" tIns="0" rIns="0" bIns="0" rtlCol="0" anchor="ctr"/>
           <a:lstStyle/>
           <a:p>
-            <a:pPr marL="0" indent="0">
+            <a:pPr indent="0" marL="0">
               <a:buNone/>
             </a:pPr>
             <a:r>
@@ -11987,13 +12096,6 @@
             <a:prstDash val="solid"/>
           </a:ln>
         </p:spPr>
-        <p:txBody>
-          <a:bodyPr/>
-          <a:lstStyle/>
-          <a:p>
-            <a:endParaRPr lang="ja-JP" altLang="en-US"/>
-          </a:p>
-        </p:txBody>
       </p:sp>
       <p:sp>
         <p:nvSpPr>
@@ -12019,13 +12121,6 @@
             <a:prstDash val="solid"/>
           </a:ln>
         </p:spPr>
-        <p:txBody>
-          <a:bodyPr/>
-          <a:lstStyle/>
-          <a:p>
-            <a:endParaRPr lang="ja-JP" altLang="en-US"/>
-          </a:p>
-        </p:txBody>
       </p:sp>
       <p:sp>
         <p:nvSpPr>
@@ -12053,13 +12148,6 @@
             <a:prstDash val="solid"/>
           </a:ln>
         </p:spPr>
-        <p:txBody>
-          <a:bodyPr/>
-          <a:lstStyle/>
-          <a:p>
-            <a:endParaRPr lang="ja-JP" altLang="en-US"/>
-          </a:p>
-        </p:txBody>
       </p:sp>
       <p:sp>
         <p:nvSpPr>
@@ -12082,7 +12170,7 @@
           <a:bodyPr wrap="square" lIns="0" tIns="0" rIns="0" bIns="0" rtlCol="0" anchor="ctr"/>
           <a:lstStyle/>
           <a:p>
-            <a:pPr marL="0" indent="0">
+            <a:pPr indent="0" marL="0">
               <a:buNone/>
             </a:pPr>
             <a:r>
@@ -12121,7 +12209,7 @@
           <a:bodyPr wrap="square" lIns="0" tIns="0" rIns="0" bIns="0" rtlCol="0" anchor="ctr"/>
           <a:lstStyle/>
           <a:p>
-            <a:pPr marL="0" indent="0">
+            <a:pPr indent="0" marL="0">
               <a:buNone/>
             </a:pPr>
             <a:r>
@@ -12160,7 +12248,7 @@
           <a:bodyPr wrap="square" lIns="0" tIns="0" rIns="0" bIns="0" rtlCol="0" anchor="ctr"/>
           <a:lstStyle/>
           <a:p>
-            <a:pPr marL="0" indent="0">
+            <a:pPr indent="0" marL="0">
               <a:buNone/>
             </a:pPr>
             <a:r>
@@ -12199,7 +12287,7 @@
           <a:bodyPr wrap="square" lIns="0" tIns="0" rIns="0" bIns="0" rtlCol="0" anchor="ctr"/>
           <a:lstStyle/>
           <a:p>
-            <a:pPr marL="0" indent="0">
+            <a:pPr indent="0" marL="0">
               <a:buNone/>
             </a:pPr>
             <a:r>
@@ -12238,7 +12326,7 @@
           <a:bodyPr wrap="square" lIns="0" tIns="0" rIns="0" bIns="0" rtlCol="0" anchor="ctr"/>
           <a:lstStyle/>
           <a:p>
-            <a:pPr marL="0" indent="0">
+            <a:pPr indent="0" marL="0">
               <a:buNone/>
             </a:pPr>
             <a:r>
@@ -12277,7 +12365,7 @@
           <a:bodyPr wrap="square" lIns="0" tIns="0" rIns="0" bIns="0" rtlCol="0" anchor="ctr"/>
           <a:lstStyle/>
           <a:p>
-            <a:pPr marL="0" indent="0">
+            <a:pPr indent="0" marL="0">
               <a:buNone/>
             </a:pPr>
             <a:r>
@@ -12316,7 +12404,7 @@
           <a:bodyPr wrap="square" lIns="0" tIns="0" rIns="0" bIns="0" rtlCol="0" anchor="ctr"/>
           <a:lstStyle/>
           <a:p>
-            <a:pPr marL="0" indent="0">
+            <a:pPr indent="0" marL="0">
               <a:buNone/>
             </a:pPr>
             <a:r>
@@ -12355,7 +12443,7 @@
           <a:bodyPr wrap="square" lIns="0" tIns="0" rIns="0" bIns="0" rtlCol="0" anchor="ctr"/>
           <a:lstStyle/>
           <a:p>
-            <a:pPr marL="0" indent="0">
+            <a:pPr indent="0" marL="0">
               <a:buNone/>
             </a:pPr>
             <a:r>
@@ -12394,7 +12482,7 @@
           <a:bodyPr wrap="square" lIns="0" tIns="0" rIns="0" bIns="0" rtlCol="0" anchor="ctr"/>
           <a:lstStyle/>
           <a:p>
-            <a:pPr marL="0" indent="0">
+            <a:pPr indent="0" marL="0">
               <a:buNone/>
             </a:pPr>
             <a:r>
@@ -12433,7 +12521,7 @@
           <a:bodyPr wrap="square" lIns="0" tIns="0" rIns="0" bIns="0" rtlCol="0" anchor="ctr"/>
           <a:lstStyle/>
           <a:p>
-            <a:pPr marL="0" indent="0" algn="r">
+            <a:pPr algn="r" indent="0" marL="0">
               <a:buNone/>
             </a:pPr>
             <a:r>
@@ -12467,7 +12555,6 @@
         <a:solidFill>
           <a:srgbClr val="FFFFFF"/>
         </a:solidFill>
-        <a:effectLst/>
       </p:bgPr>
     </p:bg>
     <p:spTree>
@@ -12505,7 +12592,7 @@
           <a:bodyPr wrap="square" lIns="0" tIns="0" rIns="0" bIns="0" rtlCol="0" anchor="ctr"/>
           <a:lstStyle/>
           <a:p>
-            <a:pPr marL="0" indent="0">
+            <a:pPr indent="0" marL="0">
               <a:buNone/>
             </a:pPr>
             <a:r>
@@ -12544,7 +12631,7 @@
           <a:bodyPr wrap="square" lIns="0" tIns="0" rIns="0" bIns="0" rtlCol="0" anchor="ctr"/>
           <a:lstStyle/>
           <a:p>
-            <a:pPr marL="0" indent="0">
+            <a:pPr indent="0" marL="0">
               <a:buNone/>
             </a:pPr>
             <a:r>
@@ -12583,7 +12670,7 @@
           <a:bodyPr wrap="square" lIns="0" tIns="0" rIns="0" bIns="0" rtlCol="0" anchor="ctr"/>
           <a:lstStyle/>
           <a:p>
-            <a:pPr marL="0" indent="0" algn="r">
+            <a:pPr algn="r" indent="0" marL="0">
               <a:buNone/>
             </a:pPr>
             <a:r>
@@ -12617,7 +12704,6 @@
         <a:solidFill>
           <a:srgbClr val="FFFFFF"/>
         </a:solidFill>
-        <a:effectLst/>
       </p:bgPr>
     </p:bg>
     <p:spTree>
@@ -12655,7 +12741,7 @@
           <a:bodyPr wrap="square" lIns="0" tIns="0" rIns="0" bIns="0" rtlCol="0" anchor="ctr"/>
           <a:lstStyle/>
           <a:p>
-            <a:pPr marL="0" indent="0">
+            <a:pPr indent="0" marL="0">
               <a:buNone/>
             </a:pPr>
             <a:r>
@@ -12694,7 +12780,7 @@
           <a:bodyPr wrap="square" lIns="0" tIns="0" rIns="0" bIns="0" rtlCol="0" anchor="ctr"/>
           <a:lstStyle/>
           <a:p>
-            <a:pPr marL="0" indent="0">
+            <a:pPr indent="0" marL="0">
               <a:buNone/>
             </a:pPr>
             <a:r>
@@ -12733,7 +12819,7 @@
           <a:bodyPr wrap="square" lIns="0" tIns="0" rIns="0" bIns="0" rtlCol="0" anchor="ctr"/>
           <a:lstStyle/>
           <a:p>
-            <a:pPr marL="0" indent="0" algn="r">
+            <a:pPr algn="r" indent="0" marL="0">
               <a:buNone/>
             </a:pPr>
             <a:r>
@@ -12767,7 +12853,6 @@
         <a:solidFill>
           <a:srgbClr val="FFFFFF"/>
         </a:solidFill>
-        <a:effectLst/>
       </p:bgPr>
     </p:bg>
     <p:spTree>
@@ -12805,11 +12890,11 @@
           <a:bodyPr wrap="square" lIns="0" tIns="0" rIns="0" bIns="0" rtlCol="0" anchor="ctr"/>
           <a:lstStyle/>
           <a:p>
-            <a:pPr marL="0" indent="0">
-              <a:buNone/>
-            </a:pPr>
-            <a:r>
-              <a:rPr lang="ja-JP" altLang="en-US" sz="2700" b="1" dirty="0">
+            <a:pPr indent="0" marL="0">
+              <a:buNone/>
+            </a:pPr>
+            <a:r>
+              <a:rPr lang="en-US" sz="2700" b="1" dirty="0">
                 <a:solidFill>
                   <a:srgbClr val="0E2841"/>
                 </a:solidFill>
@@ -12817,7 +12902,7 @@
                 <a:ea typeface="游ゴシック" pitchFamily="34" charset="-122"/>
                 <a:cs typeface="游ゴシック" pitchFamily="34" charset="-120"/>
               </a:rPr>
-              <a:t>インターンを通して学んだこと・感じたこと</a:t>
+              <a:t>技術への感度の高さ、議論できる環境、熟練者の知識の深さ</a:t>
             </a:r>
             <a:endParaRPr lang="en-US" sz="2700" dirty="0"/>
           </a:p>
@@ -12849,20 +12934,13 @@
             <a:prstDash val="solid"/>
           </a:ln>
           <a:effectLst>
-            <a:outerShdw blurRad="127000" dist="25400" dir="5400000" algn="bl" rotWithShape="0">
+            <a:outerShdw sx="100000" sy="100000" kx="0" ky="0" algn="bl" rotWithShape="0" blurRad="127000" dist="25400" dir="5400000">
               <a:srgbClr val="9AA8B4">
                 <a:alpha val="20000"/>
               </a:srgbClr>
             </a:outerShdw>
           </a:effectLst>
         </p:spPr>
-        <p:txBody>
-          <a:bodyPr/>
-          <a:lstStyle/>
-          <a:p>
-            <a:endParaRPr lang="ja-JP" altLang="en-US"/>
-          </a:p>
-        </p:txBody>
       </p:sp>
       <p:sp>
         <p:nvSpPr>
@@ -12890,13 +12968,6 @@
             <a:prstDash val="solid"/>
           </a:ln>
         </p:spPr>
-        <p:txBody>
-          <a:bodyPr/>
-          <a:lstStyle/>
-          <a:p>
-            <a:endParaRPr lang="ja-JP" altLang="en-US"/>
-          </a:p>
-        </p:txBody>
       </p:sp>
       <p:sp>
         <p:nvSpPr>
@@ -12919,7 +12990,7 @@
           <a:bodyPr wrap="square" lIns="0" tIns="0" rIns="0" bIns="0" rtlCol="0" anchor="ctr"/>
           <a:lstStyle/>
           <a:p>
-            <a:pPr marL="0" indent="0" algn="ctr">
+            <a:pPr algn="ctr" indent="0" marL="0">
               <a:buNone/>
             </a:pPr>
             <a:r>
@@ -12958,7 +13029,7 @@
           <a:bodyPr wrap="square" lIns="0" tIns="0" rIns="0" bIns="0" rtlCol="0" anchor="ctr"/>
           <a:lstStyle/>
           <a:p>
-            <a:pPr marL="0" indent="0">
+            <a:pPr indent="0" marL="0">
               <a:lnSpc>
                 <a:spcPct val="120000"/>
               </a:lnSpc>
@@ -12978,7 +13049,7 @@
             <a:endParaRPr lang="en-US" sz="1600" dirty="0"/>
           </a:p>
           <a:p>
-            <a:pPr marL="0" indent="0">
+            <a:pPr indent="0" marL="0">
               <a:lnSpc>
                 <a:spcPct val="120000"/>
               </a:lnSpc>
@@ -13119,20 +13190,13 @@
             <a:prstDash val="solid"/>
           </a:ln>
           <a:effectLst>
-            <a:outerShdw blurRad="127000" dist="25400" dir="5400000" algn="bl" rotWithShape="0">
+            <a:outerShdw sx="100000" sy="100000" kx="0" ky="0" algn="bl" rotWithShape="0" blurRad="127000" dist="25400" dir="5400000">
               <a:srgbClr val="9AA8B4">
                 <a:alpha val="20000"/>
               </a:srgbClr>
             </a:outerShdw>
           </a:effectLst>
         </p:spPr>
-        <p:txBody>
-          <a:bodyPr/>
-          <a:lstStyle/>
-          <a:p>
-            <a:endParaRPr lang="ja-JP" altLang="en-US"/>
-          </a:p>
-        </p:txBody>
       </p:sp>
       <p:sp>
         <p:nvSpPr>
@@ -13160,13 +13224,6 @@
             <a:prstDash val="solid"/>
           </a:ln>
         </p:spPr>
-        <p:txBody>
-          <a:bodyPr/>
-          <a:lstStyle/>
-          <a:p>
-            <a:endParaRPr lang="ja-JP" altLang="en-US"/>
-          </a:p>
-        </p:txBody>
       </p:sp>
       <p:sp>
         <p:nvSpPr>
@@ -13189,7 +13246,7 @@
           <a:bodyPr wrap="square" lIns="0" tIns="0" rIns="0" bIns="0" rtlCol="0" anchor="ctr"/>
           <a:lstStyle/>
           <a:p>
-            <a:pPr marL="0" indent="0" algn="ctr">
+            <a:pPr algn="ctr" indent="0" marL="0">
               <a:buNone/>
             </a:pPr>
             <a:r>
@@ -13228,7 +13285,7 @@
           <a:bodyPr wrap="square" lIns="0" tIns="0" rIns="0" bIns="0" rtlCol="0" anchor="ctr"/>
           <a:lstStyle/>
           <a:p>
-            <a:pPr marL="0" indent="0">
+            <a:pPr indent="0" marL="0">
               <a:lnSpc>
                 <a:spcPct val="120000"/>
               </a:lnSpc>
@@ -13369,20 +13426,13 @@
             <a:prstDash val="solid"/>
           </a:ln>
           <a:effectLst>
-            <a:outerShdw blurRad="127000" dist="25400" dir="5400000" algn="bl" rotWithShape="0">
+            <a:outerShdw sx="100000" sy="100000" kx="0" ky="0" algn="bl" rotWithShape="0" blurRad="127000" dist="25400" dir="5400000">
               <a:srgbClr val="9AA8B4">
                 <a:alpha val="20000"/>
               </a:srgbClr>
             </a:outerShdw>
           </a:effectLst>
         </p:spPr>
-        <p:txBody>
-          <a:bodyPr/>
-          <a:lstStyle/>
-          <a:p>
-            <a:endParaRPr lang="ja-JP" altLang="en-US"/>
-          </a:p>
-        </p:txBody>
       </p:sp>
       <p:sp>
         <p:nvSpPr>
@@ -13410,13 +13460,6 @@
             <a:prstDash val="solid"/>
           </a:ln>
         </p:spPr>
-        <p:txBody>
-          <a:bodyPr/>
-          <a:lstStyle/>
-          <a:p>
-            <a:endParaRPr lang="ja-JP" altLang="en-US"/>
-          </a:p>
-        </p:txBody>
       </p:sp>
       <p:sp>
         <p:nvSpPr>
@@ -13439,7 +13482,7 @@
           <a:bodyPr wrap="square" lIns="0" tIns="0" rIns="0" bIns="0" rtlCol="0" anchor="ctr"/>
           <a:lstStyle/>
           <a:p>
-            <a:pPr marL="0" indent="0" algn="ctr">
+            <a:pPr algn="ctr" indent="0" marL="0">
               <a:buNone/>
             </a:pPr>
             <a:r>
@@ -13451,29 +13494,7 @@
                 <a:ea typeface="游ゴシック" pitchFamily="34" charset="-122"/>
                 <a:cs typeface="游ゴシック" pitchFamily="34" charset="-120"/>
               </a:rPr>
-              <a:t>③ </a:t>
-            </a:r>
-            <a:r>
-              <a:rPr lang="ja-JP" altLang="en-US" sz="1150" b="1" dirty="0">
-                <a:solidFill>
-                  <a:srgbClr val="FFFFFF"/>
-                </a:solidFill>
-                <a:latin typeface="游ゴシック" pitchFamily="34" charset="0"/>
-                <a:ea typeface="游ゴシック" pitchFamily="34" charset="-122"/>
-                <a:cs typeface="游ゴシック" pitchFamily="34" charset="-120"/>
-              </a:rPr>
-              <a:t>トヨタの</a:t>
-            </a:r>
-            <a:r>
-              <a:rPr lang="en-US" sz="1150" b="1" dirty="0" err="1">
-                <a:solidFill>
-                  <a:srgbClr val="FFFFFF"/>
-                </a:solidFill>
-                <a:latin typeface="游ゴシック" pitchFamily="34" charset="0"/>
-                <a:ea typeface="游ゴシック" pitchFamily="34" charset="-122"/>
-                <a:cs typeface="游ゴシック" pitchFamily="34" charset="-120"/>
-              </a:rPr>
-              <a:t>熟練者</a:t>
+              <a:t>③ 熟練者との対話</a:t>
             </a:r>
             <a:endParaRPr lang="en-US" sz="1150" dirty="0"/>
           </a:p>
@@ -13500,7 +13521,7 @@
           <a:bodyPr wrap="square" lIns="0" tIns="0" rIns="0" bIns="0" rtlCol="0" anchor="ctr"/>
           <a:lstStyle/>
           <a:p>
-            <a:pPr marL="0" indent="0">
+            <a:pPr indent="0" marL="0">
               <a:lnSpc>
                 <a:spcPct val="120000"/>
               </a:lnSpc>
@@ -13520,7 +13541,7 @@
             <a:endParaRPr lang="en-US" sz="1600" dirty="0"/>
           </a:p>
           <a:p>
-            <a:pPr marL="0" indent="0">
+            <a:pPr indent="0" marL="0">
               <a:lnSpc>
                 <a:spcPct val="120000"/>
               </a:lnSpc>
@@ -13661,13 +13682,6 @@
             <a:prstDash val="solid"/>
           </a:ln>
         </p:spPr>
-        <p:txBody>
-          <a:bodyPr/>
-          <a:lstStyle/>
-          <a:p>
-            <a:endParaRPr lang="ja-JP" altLang="en-US"/>
-          </a:p>
-        </p:txBody>
       </p:sp>
       <p:sp>
         <p:nvSpPr>
@@ -13690,7 +13704,7 @@
           <a:bodyPr wrap="square" lIns="0" tIns="0" rIns="0" bIns="0" rtlCol="0" anchor="ctr"/>
           <a:lstStyle/>
           <a:p>
-            <a:pPr marL="0" indent="0">
+            <a:pPr indent="0" marL="0">
               <a:buNone/>
             </a:pPr>
             <a:r>
@@ -13729,7 +13743,7 @@
           <a:bodyPr wrap="square" lIns="0" tIns="0" rIns="0" bIns="0" rtlCol="0" anchor="ctr"/>
           <a:lstStyle/>
           <a:p>
-            <a:pPr marL="0" indent="0">
+            <a:pPr indent="0" marL="0">
               <a:buNone/>
             </a:pPr>
             <a:r>
@@ -13768,7 +13782,7 @@
           <a:bodyPr wrap="square" lIns="0" tIns="0" rIns="0" bIns="0" rtlCol="0" anchor="ctr"/>
           <a:lstStyle/>
           <a:p>
-            <a:pPr marL="0" indent="0">
+            <a:pPr indent="0" marL="0">
               <a:buNone/>
             </a:pPr>
             <a:r>
@@ -13807,7 +13821,7 @@
           <a:bodyPr wrap="square" lIns="0" tIns="0" rIns="0" bIns="0" rtlCol="0" anchor="ctr"/>
           <a:lstStyle/>
           <a:p>
-            <a:pPr marL="0" indent="0" algn="r">
+            <a:pPr algn="r" indent="0" marL="0">
               <a:buNone/>
             </a:pPr>
             <a:r>
@@ -13841,7 +13855,6 @@
         <a:solidFill>
           <a:srgbClr val="0E2841"/>
         </a:solidFill>
-        <a:effectLst/>
       </p:bgPr>
     </p:bg>
     <p:spTree>
@@ -13882,13 +13895,6 @@
             <a:prstDash val="solid"/>
           </a:ln>
         </p:spPr>
-        <p:txBody>
-          <a:bodyPr/>
-          <a:lstStyle/>
-          <a:p>
-            <a:endParaRPr lang="ja-JP" altLang="en-US"/>
-          </a:p>
-        </p:txBody>
       </p:sp>
       <p:sp>
         <p:nvSpPr>
@@ -13911,7 +13917,7 @@
           <a:bodyPr wrap="square" lIns="0" tIns="0" rIns="0" bIns="0" rtlCol="0" anchor="ctr"/>
           <a:lstStyle/>
           <a:p>
-            <a:pPr marL="0" indent="0">
+            <a:pPr indent="0" marL="0">
               <a:buNone/>
             </a:pPr>
             <a:r>
@@ -13950,7 +13956,7 @@
           <a:bodyPr wrap="square" lIns="0" tIns="0" rIns="0" bIns="0" rtlCol="0" anchor="ctr"/>
           <a:lstStyle/>
           <a:p>
-            <a:pPr marL="0" indent="0">
+            <a:pPr indent="0" marL="0">
               <a:buNone/>
             </a:pPr>
             <a:r>
@@ -13989,7 +13995,7 @@
           <a:bodyPr wrap="square" lIns="0" tIns="0" rIns="0" bIns="0" rtlCol="0" anchor="ctr"/>
           <a:lstStyle/>
           <a:p>
-            <a:pPr marL="0" indent="0" algn="r">
+            <a:pPr algn="r" indent="0" marL="0">
               <a:buNone/>
             </a:pPr>
             <a:r>
@@ -14308,319 +14314,4 @@
     </a:ext>
   </a:extLst>
 </a:theme>
-</file>
-
-<file path=ppt/theme/theme2.xml><?xml version="1.0" encoding="utf-8"?>
-<a:theme xmlns:a="http://schemas.openxmlformats.org/drawingml/2006/main" name="Office テーマ">
-  <a:themeElements>
-    <a:clrScheme name="Office">
-      <a:dk1>
-        <a:sysClr val="windowText" lastClr="000000"/>
-      </a:dk1>
-      <a:lt1>
-        <a:sysClr val="window" lastClr="FFFFFF"/>
-      </a:lt1>
-      <a:dk2>
-        <a:srgbClr val="0E2841"/>
-      </a:dk2>
-      <a:lt2>
-        <a:srgbClr val="E8E8E8"/>
-      </a:lt2>
-      <a:accent1>
-        <a:srgbClr val="156082"/>
-      </a:accent1>
-      <a:accent2>
-        <a:srgbClr val="E97132"/>
-      </a:accent2>
-      <a:accent3>
-        <a:srgbClr val="196B24"/>
-      </a:accent3>
-      <a:accent4>
-        <a:srgbClr val="0F9ED5"/>
-      </a:accent4>
-      <a:accent5>
-        <a:srgbClr val="A02B93"/>
-      </a:accent5>
-      <a:accent6>
-        <a:srgbClr val="4EA72E"/>
-      </a:accent6>
-      <a:hlink>
-        <a:srgbClr val="467886"/>
-      </a:hlink>
-      <a:folHlink>
-        <a:srgbClr val="96607D"/>
-      </a:folHlink>
-    </a:clrScheme>
-    <a:fontScheme name="Office">
-      <a:majorFont>
-        <a:latin typeface="游ゴシック Light" panose="02110004020202020204"/>
-        <a:ea typeface=""/>
-        <a:cs typeface=""/>
-        <a:font script="Jpan" typeface="游ゴシック Light"/>
-        <a:font script="Hang" typeface="맑은 고딕"/>
-        <a:font script="Hans" typeface="等线 Light"/>
-        <a:font script="Hant" typeface="新細明體"/>
-        <a:font script="Arab" typeface="Times New Roman"/>
-        <a:font script="Hebr" typeface="Times New Roman"/>
-        <a:font script="Thai" typeface="Angsana New"/>
-        <a:font script="Ethi" typeface="Nyala"/>
-        <a:font script="Beng" typeface="Vrinda"/>
-        <a:font script="Gujr" typeface="Shruti"/>
-        <a:font script="Khmr" typeface="MoolBoran"/>
-        <a:font script="Knda" typeface="Tunga"/>
-        <a:font script="Guru" typeface="Raavi"/>
-        <a:font script="Cans" typeface="Euphemia"/>
-        <a:font script="Cher" typeface="Plantagenet Cherokee"/>
-        <a:font script="Yiii" typeface="Microsoft Yi Baiti"/>
-        <a:font script="Tibt" typeface="Microsoft Himalaya"/>
-        <a:font script="Thaa" typeface="MV Boli"/>
-        <a:font script="Deva" typeface="Mangal"/>
-        <a:font script="Telu" typeface="Gautami"/>
-        <a:font script="Taml" typeface="Latha"/>
-        <a:font script="Syrc" typeface="Estrangelo Edessa"/>
-        <a:font script="Orya" typeface="Kalinga"/>
-        <a:font script="Mlym" typeface="Kartika"/>
-        <a:font script="Laoo" typeface="DokChampa"/>
-        <a:font script="Sinh" typeface="Iskoola Pota"/>
-        <a:font script="Mong" typeface="Mongolian Baiti"/>
-        <a:font script="Viet" typeface="Times New Roman"/>
-        <a:font script="Uigh" typeface="Microsoft Uighur"/>
-        <a:font script="Geor" typeface="Sylfaen"/>
-        <a:font script="Armn" typeface="Arial"/>
-        <a:font script="Bugi" typeface="Leelawadee UI"/>
-        <a:font script="Bopo" typeface="Microsoft JhengHei"/>
-        <a:font script="Java" typeface="Javanese Text"/>
-        <a:font script="Lisu" typeface="Segoe UI"/>
-        <a:font script="Mymr" typeface="Myanmar Text"/>
-        <a:font script="Nkoo" typeface="Ebrima"/>
-        <a:font script="Olck" typeface="Nirmala UI"/>
-        <a:font script="Osma" typeface="Ebrima"/>
-        <a:font script="Phag" typeface="Phagspa"/>
-        <a:font script="Syrn" typeface="Estrangelo Edessa"/>
-        <a:font script="Syrj" typeface="Estrangelo Edessa"/>
-        <a:font script="Syre" typeface="Estrangelo Edessa"/>
-        <a:font script="Sora" typeface="Nirmala UI"/>
-        <a:font script="Tale" typeface="Microsoft Tai Le"/>
-        <a:font script="Talu" typeface="Microsoft New Tai Lue"/>
-        <a:font script="Tfng" typeface="Ebrima"/>
-      </a:majorFont>
-      <a:minorFont>
-        <a:latin typeface="游ゴシック" panose="02110004020202020204"/>
-        <a:ea typeface=""/>
-        <a:cs typeface=""/>
-        <a:font script="Jpan" typeface="游ゴシック"/>
-        <a:font script="Hang" typeface="맑은 고딕"/>
-        <a:font script="Hans" typeface="等线"/>
-        <a:font script="Hant" typeface="新細明體"/>
-        <a:font script="Arab" typeface="Arial"/>
-        <a:font script="Hebr" typeface="Arial"/>
-        <a:font script="Thai" typeface="Cordia New"/>
-        <a:font script="Ethi" typeface="Nyala"/>
-        <a:font script="Beng" typeface="Vrinda"/>
-        <a:font script="Gujr" typeface="Shruti"/>
-        <a:font script="Khmr" typeface="DaunPenh"/>
-        <a:font script="Knda" typeface="Tunga"/>
-        <a:font script="Guru" typeface="Raavi"/>
-        <a:font script="Cans" typeface="Euphemia"/>
-        <a:font script="Cher" typeface="Plantagenet Cherokee"/>
-        <a:font script="Yiii" typeface="Microsoft Yi Baiti"/>
-        <a:font script="Tibt" typeface="Microsoft Himalaya"/>
-        <a:font script="Thaa" typeface="MV Boli"/>
-        <a:font script="Deva" typeface="Mangal"/>
-        <a:font script="Telu" typeface="Gautami"/>
-        <a:font script="Taml" typeface="Latha"/>
-        <a:font script="Syrc" typeface="Estrangelo Edessa"/>
-        <a:font script="Orya" typeface="Kalinga"/>
-        <a:font script="Mlym" typeface="Kartika"/>
-        <a:font script="Laoo" typeface="DokChampa"/>
-        <a:font script="Sinh" typeface="Iskoola Pota"/>
-        <a:font script="Mong" typeface="Mongolian Baiti"/>
-        <a:font script="Viet" typeface="Arial"/>
-        <a:font script="Uigh" typeface="Microsoft Uighur"/>
-        <a:font script="Geor" typeface="Sylfaen"/>
-        <a:font script="Armn" typeface="Arial"/>
-        <a:font script="Bugi" typeface="Leelawadee UI"/>
-        <a:font script="Bopo" typeface="Microsoft JhengHei"/>
-        <a:font script="Java" typeface="Javanese Text"/>
-        <a:font script="Lisu" typeface="Segoe UI"/>
-        <a:font script="Mymr" typeface="Myanmar Text"/>
-        <a:font script="Nkoo" typeface="Ebrima"/>
-        <a:font script="Olck" typeface="Nirmala UI"/>
-        <a:font script="Osma" typeface="Ebrima"/>
-        <a:font script="Phag" typeface="Phagspa"/>
-        <a:font script="Syrn" typeface="Estrangelo Edessa"/>
-        <a:font script="Syrj" typeface="Estrangelo Edessa"/>
-        <a:font script="Syre" typeface="Estrangelo Edessa"/>
-        <a:font script="Sora" typeface="Nirmala UI"/>
-        <a:font script="Tale" typeface="Microsoft Tai Le"/>
-        <a:font script="Talu" typeface="Microsoft New Tai Lue"/>
-        <a:font script="Tfng" typeface="Ebrima"/>
-      </a:minorFont>
-    </a:fontScheme>
-    <a:fmtScheme name="Office">
-      <a:fillStyleLst>
-        <a:solidFill>
-          <a:schemeClr val="phClr"/>
-        </a:solidFill>
-        <a:gradFill rotWithShape="1">
-          <a:gsLst>
-            <a:gs pos="0">
-              <a:schemeClr val="phClr">
-                <a:lumMod val="110000"/>
-                <a:satMod val="105000"/>
-                <a:tint val="67000"/>
-              </a:schemeClr>
-            </a:gs>
-            <a:gs pos="50000">
-              <a:schemeClr val="phClr">
-                <a:lumMod val="105000"/>
-                <a:satMod val="103000"/>
-                <a:tint val="73000"/>
-              </a:schemeClr>
-            </a:gs>
-            <a:gs pos="100000">
-              <a:schemeClr val="phClr">
-                <a:lumMod val="105000"/>
-                <a:satMod val="109000"/>
-                <a:tint val="81000"/>
-              </a:schemeClr>
-            </a:gs>
-          </a:gsLst>
-          <a:lin ang="5400000" scaled="0"/>
-        </a:gradFill>
-        <a:gradFill rotWithShape="1">
-          <a:gsLst>
-            <a:gs pos="0">
-              <a:schemeClr val="phClr">
-                <a:satMod val="103000"/>
-                <a:lumMod val="102000"/>
-                <a:tint val="94000"/>
-              </a:schemeClr>
-            </a:gs>
-            <a:gs pos="50000">
-              <a:schemeClr val="phClr">
-                <a:satMod val="110000"/>
-                <a:lumMod val="100000"/>
-                <a:shade val="100000"/>
-              </a:schemeClr>
-            </a:gs>
-            <a:gs pos="100000">
-              <a:schemeClr val="phClr">
-                <a:lumMod val="99000"/>
-                <a:satMod val="120000"/>
-                <a:shade val="78000"/>
-              </a:schemeClr>
-            </a:gs>
-          </a:gsLst>
-          <a:lin ang="5400000" scaled="0"/>
-        </a:gradFill>
-      </a:fillStyleLst>
-      <a:lnStyleLst>
-        <a:ln w="12700" cap="flat" cmpd="sng" algn="ctr">
-          <a:solidFill>
-            <a:schemeClr val="phClr"/>
-          </a:solidFill>
-          <a:prstDash val="solid"/>
-          <a:miter lim="800000"/>
-        </a:ln>
-        <a:ln w="19050" cap="flat" cmpd="sng" algn="ctr">
-          <a:solidFill>
-            <a:schemeClr val="phClr"/>
-          </a:solidFill>
-          <a:prstDash val="solid"/>
-          <a:miter lim="800000"/>
-        </a:ln>
-        <a:ln w="25400" cap="flat" cmpd="sng" algn="ctr">
-          <a:solidFill>
-            <a:schemeClr val="phClr"/>
-          </a:solidFill>
-          <a:prstDash val="solid"/>
-          <a:miter lim="800000"/>
-        </a:ln>
-      </a:lnStyleLst>
-      <a:effectStyleLst>
-        <a:effectStyle>
-          <a:effectLst/>
-        </a:effectStyle>
-        <a:effectStyle>
-          <a:effectLst/>
-        </a:effectStyle>
-        <a:effectStyle>
-          <a:effectLst>
-            <a:outerShdw blurRad="57150" dist="19050" dir="5400000" algn="ctr" rotWithShape="0">
-              <a:srgbClr val="000000">
-                <a:alpha val="63000"/>
-              </a:srgbClr>
-            </a:outerShdw>
-          </a:effectLst>
-        </a:effectStyle>
-      </a:effectStyleLst>
-      <a:bgFillStyleLst>
-        <a:solidFill>
-          <a:schemeClr val="phClr"/>
-        </a:solidFill>
-        <a:solidFill>
-          <a:schemeClr val="phClr">
-            <a:tint val="95000"/>
-            <a:satMod val="170000"/>
-          </a:schemeClr>
-        </a:solidFill>
-        <a:gradFill rotWithShape="1">
-          <a:gsLst>
-            <a:gs pos="0">
-              <a:schemeClr val="phClr">
-                <a:tint val="93000"/>
-                <a:satMod val="150000"/>
-                <a:shade val="98000"/>
-                <a:lumMod val="102000"/>
-              </a:schemeClr>
-            </a:gs>
-            <a:gs pos="50000">
-              <a:schemeClr val="phClr">
-                <a:tint val="98000"/>
-                <a:satMod val="130000"/>
-                <a:shade val="90000"/>
-                <a:lumMod val="103000"/>
-              </a:schemeClr>
-            </a:gs>
-            <a:gs pos="100000">
-              <a:schemeClr val="phClr">
-                <a:shade val="63000"/>
-                <a:satMod val="120000"/>
-              </a:schemeClr>
-            </a:gs>
-          </a:gsLst>
-          <a:lin ang="5400000" scaled="0"/>
-        </a:gradFill>
-      </a:bgFillStyleLst>
-    </a:fmtScheme>
-  </a:themeElements>
-  <a:objectDefaults>
-    <a:lnDef>
-      <a:spPr/>
-      <a:bodyPr/>
-      <a:lstStyle/>
-      <a:style>
-        <a:lnRef idx="2">
-          <a:schemeClr val="accent1"/>
-        </a:lnRef>
-        <a:fillRef idx="0">
-          <a:schemeClr val="accent1"/>
-        </a:fillRef>
-        <a:effectRef idx="1">
-          <a:schemeClr val="accent1"/>
-        </a:effectRef>
-        <a:fontRef idx="minor">
-          <a:schemeClr val="tx1"/>
-        </a:fontRef>
-      </a:style>
-    </a:lnDef>
-  </a:objectDefaults>
-  <a:extraClrSchemeLst/>
-  <a:extLst>
-    <a:ext uri="{05A4C25C-085E-4340-85A3-A5531E510DB2}">
-      <thm15:themeFamily xmlns:thm15="http://schemas.microsoft.com/office/thememl/2012/main" name="Office Theme" id="{2E142A2C-CD16-42D6-873A-C26D2A0506FA}" vid="{1BDDFF52-6CD6-40A5-AB3C-68EB2F1E4D0A}"/>
-    </a:ext>
-  </a:extLst>
-</a:theme>
 </file>
</xml_diff>